<commit_message>
adds some more testing examples for coverage
</commit_message>
<xml_diff>
--- a/Python/Lesson 11 - Testing/Lesson 11 - Testing.pptx
+++ b/Python/Lesson 11 - Testing/Lesson 11 - Testing.pptx
@@ -5,7 +5,7 @@
     <p:sldMasterId id="2147483673" r:id="rId1"/>
   </p:sldMasterIdLst>
   <p:notesMasterIdLst>
-    <p:notesMasterId r:id="rId22"/>
+    <p:notesMasterId r:id="rId24"/>
   </p:notesMasterIdLst>
   <p:sldIdLst>
     <p:sldId id="321" r:id="rId2"/>
@@ -21,13 +21,15 @@
     <p:sldId id="337" r:id="rId12"/>
     <p:sldId id="338" r:id="rId13"/>
     <p:sldId id="339" r:id="rId14"/>
-    <p:sldId id="331" r:id="rId15"/>
-    <p:sldId id="333" r:id="rId16"/>
-    <p:sldId id="329" r:id="rId17"/>
-    <p:sldId id="330" r:id="rId18"/>
-    <p:sldId id="332" r:id="rId19"/>
-    <p:sldId id="334" r:id="rId20"/>
-    <p:sldId id="313" r:id="rId21"/>
+    <p:sldId id="342" r:id="rId15"/>
+    <p:sldId id="331" r:id="rId16"/>
+    <p:sldId id="341" r:id="rId17"/>
+    <p:sldId id="340" r:id="rId18"/>
+    <p:sldId id="333" r:id="rId19"/>
+    <p:sldId id="329" r:id="rId20"/>
+    <p:sldId id="330" r:id="rId21"/>
+    <p:sldId id="332" r:id="rId22"/>
+    <p:sldId id="313" r:id="rId23"/>
   </p:sldIdLst>
   <p:sldSz cx="9144000" cy="5143500" type="screen16x9"/>
   <p:notesSz cx="6858000" cy="9144000"/>
@@ -789,6 +791,75 @@
 </p:notes>
 </file>
 
+<file path=ppt/notesSlides/notesSlide2.xml><?xml version="1.0" encoding="utf-8"?>
+<p:notes xmlns:a="http://schemas.openxmlformats.org/drawingml/2006/main" xmlns:r="http://schemas.openxmlformats.org/officeDocument/2006/relationships" xmlns:p="http://schemas.openxmlformats.org/presentationml/2006/main">
+  <p:cSld>
+    <p:spTree>
+      <p:nvGrpSpPr>
+        <p:cNvPr id="1" name=""/>
+        <p:cNvGrpSpPr/>
+        <p:nvPr/>
+      </p:nvGrpSpPr>
+      <p:grpSpPr>
+        <a:xfrm>
+          <a:off x="0" y="0"/>
+          <a:ext cx="0" cy="0"/>
+          <a:chOff x="0" y="0"/>
+          <a:chExt cx="0" cy="0"/>
+        </a:xfrm>
+      </p:grpSpPr>
+      <p:sp>
+        <p:nvSpPr>
+          <p:cNvPr id="2" name="Slide Image Placeholder 1"/>
+          <p:cNvSpPr>
+            <a:spLocks noGrp="1" noRot="1" noChangeAspect="1"/>
+          </p:cNvSpPr>
+          <p:nvPr>
+            <p:ph type="sldImg"/>
+          </p:nvPr>
+        </p:nvSpPr>
+        <p:spPr>
+          <a:xfrm>
+            <a:off x="381000" y="685800"/>
+            <a:ext cx="6096000" cy="3429000"/>
+          </a:xfrm>
+        </p:spPr>
+      </p:sp>
+      <p:sp>
+        <p:nvSpPr>
+          <p:cNvPr id="3" name="Notes Placeholder 2"/>
+          <p:cNvSpPr>
+            <a:spLocks noGrp="1"/>
+          </p:cNvSpPr>
+          <p:nvPr>
+            <p:ph type="body" idx="1"/>
+          </p:nvPr>
+        </p:nvSpPr>
+        <p:spPr/>
+        <p:txBody>
+          <a:bodyPr/>
+          <a:lstStyle/>
+          <a:p>
+            <a:r>
+              <a:rPr lang="en-US" dirty="0"/>
+              <a:t>Line 36 of inventory.py might be "covered" but you need to be careful about the 'or' statement</a:t>
+            </a:r>
+          </a:p>
+        </p:txBody>
+      </p:sp>
+    </p:spTree>
+    <p:extLst>
+      <p:ext uri="{BB962C8B-B14F-4D97-AF65-F5344CB8AC3E}">
+        <p14:creationId xmlns:p14="http://schemas.microsoft.com/office/powerpoint/2010/main" val="2776245140"/>
+      </p:ext>
+    </p:extLst>
+  </p:cSld>
+  <p:clrMapOvr>
+    <a:masterClrMapping/>
+  </p:clrMapOvr>
+</p:notes>
+</file>
+
 <file path=ppt/slideLayouts/slideLayout1.xml><?xml version="1.0" encoding="utf-8"?>
 <p:sldLayout xmlns:a="http://schemas.openxmlformats.org/drawingml/2006/main" xmlns:r="http://schemas.openxmlformats.org/officeDocument/2006/relationships" xmlns:p="http://schemas.openxmlformats.org/presentationml/2006/main" showMasterSp="0" preserve="1" userDrawn="1">
   <p:cSld name="Title Slide">
@@ -837,7 +908,7 @@
           <a:p>
             <a:fld id="{7A3E0868-4E26-4CDC-8A56-D70E2D8B12FE}" type="datetime3">
               <a:rPr lang="en-US" smtClean="0"/>
-              <a:t>15 June 2026</a:t>
+              <a:t>16 June 2026</a:t>
             </a:fld>
             <a:endParaRPr lang="en-US"/>
           </a:p>
@@ -3416,7 +3487,7 @@
           <a:p>
             <a:fld id="{A7B8021B-6105-4216-96FC-94348F216D0E}" type="datetime3">
               <a:rPr lang="en-US" smtClean="0"/>
-              <a:t>15 June 2026</a:t>
+              <a:t>16 June 2026</a:t>
             </a:fld>
             <a:endParaRPr lang="en-US"/>
           </a:p>
@@ -5137,7 +5208,7 @@
           <a:p>
             <a:fld id="{5D27CFAB-73E6-44A8-B862-B3306344E3F2}" type="datetime3">
               <a:rPr lang="en-US" smtClean="0"/>
-              <a:t>15 June 2026</a:t>
+              <a:t>16 June 2026</a:t>
             </a:fld>
             <a:endParaRPr lang="en-US"/>
           </a:p>
@@ -6951,7 +7022,7 @@
           <a:p>
             <a:fld id="{A9B2E784-A5F5-4301-881B-94AC8DBF9DED}" type="datetime3">
               <a:rPr lang="en-US" smtClean="0"/>
-              <a:t>15 June 2026</a:t>
+              <a:t>16 June 2026</a:t>
             </a:fld>
             <a:endParaRPr lang="en-US"/>
           </a:p>
@@ -7133,7 +7204,7 @@
           <a:p>
             <a:fld id="{18EAB3A5-9E92-4BB9-8F22-9632B4FBEDBA}" type="datetime3">
               <a:rPr lang="en-US" smtClean="0"/>
-              <a:t>15 June 2026</a:t>
+              <a:t>16 June 2026</a:t>
             </a:fld>
             <a:endParaRPr lang="en-US"/>
           </a:p>
@@ -7363,7 +7434,7 @@
           <a:p>
             <a:fld id="{40923810-5FB2-48C9-96CA-1DE2C4773142}" type="datetime3">
               <a:rPr lang="en-US" smtClean="0"/>
-              <a:t>15 June 2026</a:t>
+              <a:t>16 June 2026</a:t>
             </a:fld>
             <a:endParaRPr lang="en-US"/>
           </a:p>
@@ -7662,7 +7733,7 @@
           <a:p>
             <a:fld id="{E50EFF4B-86EB-42FB-93EA-7D8F9CB2466F}" type="datetime3">
               <a:rPr lang="en-US" smtClean="0"/>
-              <a:t>15 June 2026</a:t>
+              <a:t>16 June 2026</a:t>
             </a:fld>
             <a:endParaRPr lang="en-US"/>
           </a:p>
@@ -8292,7 +8363,7 @@
           <a:p>
             <a:fld id="{FB14FC24-E041-45E9-9A72-E5755A86890F}" type="datetime3">
               <a:rPr lang="en-US" smtClean="0"/>
-              <a:t>15 June 2026</a:t>
+              <a:t>16 June 2026</a:t>
             </a:fld>
             <a:endParaRPr lang="en-US"/>
           </a:p>
@@ -9179,7 +9250,7 @@
           <a:p>
             <a:fld id="{98A19125-94A7-4474-858C-FD9C4ABE9DDA}" type="datetime3">
               <a:rPr lang="en-US" smtClean="0"/>
-              <a:t>15 June 2026</a:t>
+              <a:t>16 June 2026</a:t>
             </a:fld>
             <a:endParaRPr lang="en-US"/>
           </a:p>
@@ -10318,7 +10389,7 @@
           <a:p>
             <a:fld id="{3BA0343D-C8D8-43CE-BB79-50DEA219DB07}" type="datetime3">
               <a:rPr lang="en-US" smtClean="0"/>
-              <a:t>15 June 2026</a:t>
+              <a:t>16 June 2026</a:t>
             </a:fld>
             <a:endParaRPr lang="en-US"/>
           </a:p>
@@ -10610,7 +10681,7 @@
           <a:p>
             <a:fld id="{453BD212-0B9F-4987-965F-AC83B2FC354F}" type="datetime3">
               <a:rPr lang="en-US" smtClean="0"/>
-              <a:t>15 June 2026</a:t>
+              <a:t>16 June 2026</a:t>
             </a:fld>
             <a:endParaRPr lang="en-US"/>
           </a:p>
@@ -10855,7 +10926,7 @@
           <a:p>
             <a:fld id="{6DDC931E-8CBE-4A3F-A034-9B6122C6DCDB}" type="datetime3">
               <a:rPr lang="en-US" smtClean="0"/>
-              <a:t>15 June 2026</a:t>
+              <a:t>16 June 2026</a:t>
             </a:fld>
             <a:endParaRPr lang="en-US"/>
           </a:p>
@@ -12633,7 +12704,7 @@
           <a:p>
             <a:fld id="{220AF9C2-5E8A-4308-AE6B-CA9B65007D0E}" type="datetime3">
               <a:rPr lang="en-US" smtClean="0"/>
-              <a:t>15 June 2026</a:t>
+              <a:t>16 June 2026</a:t>
             </a:fld>
             <a:endParaRPr lang="en-US"/>
           </a:p>
@@ -12949,7 +13020,7 @@
           <a:p>
             <a:fld id="{FF31E861-D2AF-431D-860B-DCF67C218052}" type="datetime3">
               <a:rPr lang="en-US" smtClean="0"/>
-              <a:t>15 June 2026</a:t>
+              <a:t>16 June 2026</a:t>
             </a:fld>
             <a:endParaRPr lang="en-US"/>
           </a:p>
@@ -13231,7 +13302,7 @@
           <a:p>
             <a:fld id="{D1DA25B2-AAF1-4C1F-AA38-12D5BFA7D4C8}" type="datetime3">
               <a:rPr lang="en-US" smtClean="0"/>
-              <a:t>15 June 2026</a:t>
+              <a:t>16 June 2026</a:t>
             </a:fld>
             <a:endParaRPr lang="en-US"/>
           </a:p>
@@ -13513,7 +13584,7 @@
           <a:p>
             <a:fld id="{A25C0F39-45D0-48E9-90B3-7FE8FCE561C8}" type="datetime3">
               <a:rPr lang="en-US" smtClean="0"/>
-              <a:t>15 June 2026</a:t>
+              <a:t>16 June 2026</a:t>
             </a:fld>
             <a:endParaRPr lang="en-US"/>
           </a:p>
@@ -14023,7 +14094,7 @@
           <a:p>
             <a:fld id="{9BAF1A3D-92FA-4F24-9781-74AFA516A230}" type="datetime3">
               <a:rPr lang="en-US" smtClean="0"/>
-              <a:t>15 June 2026</a:t>
+              <a:t>16 June 2026</a:t>
             </a:fld>
             <a:endParaRPr lang="en-US"/>
           </a:p>
@@ -14150,7 +14221,7 @@
           <a:p>
             <a:fld id="{5719C672-856D-4617-A693-8FE15749A9B7}" type="datetime3">
               <a:rPr lang="en-US" smtClean="0"/>
-              <a:t>15 June 2026</a:t>
+              <a:t>16 June 2026</a:t>
             </a:fld>
             <a:endParaRPr lang="en-US"/>
           </a:p>
@@ -14285,7 +14356,7 @@
           <a:p>
             <a:fld id="{5F6C764D-A39E-4C03-B161-E0BC66E8883B}" type="datetime3">
               <a:rPr lang="en-US" smtClean="0"/>
-              <a:t>15 June 2026</a:t>
+              <a:t>16 June 2026</a:t>
             </a:fld>
             <a:endParaRPr lang="en-US"/>
           </a:p>
@@ -14527,7 +14598,7 @@
           <a:p>
             <a:fld id="{6E3E33F9-20B7-4995-BE7D-165DBB597850}" type="datetime3">
               <a:rPr lang="en-US" smtClean="0"/>
-              <a:t>15 June 2026</a:t>
+              <a:t>16 June 2026</a:t>
             </a:fld>
             <a:endParaRPr lang="en-US"/>
           </a:p>
@@ -14640,7 +14711,7 @@
           <a:p>
             <a:fld id="{CD41C263-3501-4369-A962-62B6BF915CDE}" type="datetime3">
               <a:rPr lang="en-US" smtClean="0"/>
-              <a:t>15 June 2026</a:t>
+              <a:t>16 June 2026</a:t>
             </a:fld>
             <a:endParaRPr lang="en-US"/>
           </a:p>
@@ -15046,7 +15117,7 @@
           <a:p>
             <a:fld id="{B06F3EBE-B2E8-4992-9F00-9E4B44F057C0}" type="datetime3">
               <a:rPr lang="en-US" smtClean="0"/>
-              <a:t>15 June 2026</a:t>
+              <a:t>16 June 2026</a:t>
             </a:fld>
             <a:endParaRPr lang="en-US"/>
           </a:p>
@@ -15178,7 +15249,7 @@
           <a:p>
             <a:fld id="{D41656AB-D2E1-472E-8B95-0DF5C6E1D623}" type="datetime3">
               <a:rPr lang="en-US" smtClean="0"/>
-              <a:t>15 June 2026</a:t>
+              <a:t>16 June 2026</a:t>
             </a:fld>
             <a:endParaRPr lang="en-US"/>
           </a:p>
@@ -19328,7 +19399,7 @@
           <a:p>
             <a:fld id="{AD622D1A-DF83-41A8-85FF-04D90BF831D3}" type="datetime3">
               <a:rPr lang="en-US" smtClean="0"/>
-              <a:t>15 June 2026</a:t>
+              <a:t>16 June 2026</a:t>
             </a:fld>
             <a:endParaRPr lang="en-US"/>
           </a:p>
@@ -19584,7 +19655,7 @@
           <a:p>
             <a:fld id="{334F72C3-CDF3-44A8-B602-1649B1728485}" type="datetime3">
               <a:rPr lang="en-US" smtClean="0"/>
-              <a:t>15 June 2026</a:t>
+              <a:t>16 June 2026</a:t>
             </a:fld>
             <a:endParaRPr lang="en-US"/>
           </a:p>
@@ -19900,7 +19971,7 @@
           <a:p>
             <a:fld id="{1E0132BA-B5E7-4FFD-AF6C-169169D47D4A}" type="datetime3">
               <a:rPr lang="en-US" smtClean="0"/>
-              <a:t>15 June 2026</a:t>
+              <a:t>16 June 2026</a:t>
             </a:fld>
             <a:endParaRPr lang="en-US"/>
           </a:p>
@@ -20393,7 +20464,7 @@
           <a:p>
             <a:fld id="{81A30091-1C2A-4151-8D3C-D1E47A72615F}" type="datetime3">
               <a:rPr lang="en-US" smtClean="0"/>
-              <a:t>15 June 2026</a:t>
+              <a:t>16 June 2026</a:t>
             </a:fld>
             <a:endParaRPr lang="en-US"/>
           </a:p>
@@ -21054,7 +21125,7 @@
           <a:p>
             <a:fld id="{35D703CE-07B4-4C05-A488-B4566700621F}" type="datetime3">
               <a:rPr lang="en-US" smtClean="0"/>
-              <a:t>15 June 2026</a:t>
+              <a:t>16 June 2026</a:t>
             </a:fld>
             <a:endParaRPr lang="en-US"/>
           </a:p>
@@ -22124,7 +22195,7 @@
           <a:p>
             <a:fld id="{694BD61C-20BA-43AF-A21F-1DAFB3200099}" type="datetime3">
               <a:rPr lang="en-US" smtClean="0"/>
-              <a:t>15 June 2026</a:t>
+              <a:t>16 June 2026</a:t>
             </a:fld>
             <a:endParaRPr lang="en-US"/>
           </a:p>
@@ -22611,7 +22682,7 @@
           <a:p>
             <a:fld id="{CABCB1B0-B6E5-4DD1-BB55-95C076D6C0C8}" type="datetime3">
               <a:rPr lang="en-US" smtClean="0"/>
-              <a:t>15 June 2026</a:t>
+              <a:t>16 June 2026</a:t>
             </a:fld>
             <a:endParaRPr lang="en-US"/>
           </a:p>
@@ -24660,6 +24731,64 @@
           <a:p>
             <a:endParaRPr lang="en-US" dirty="0"/>
           </a:p>
+          <a:p>
+            <a:pPr marL="0" indent="0">
+              <a:buNone/>
+            </a:pPr>
+            <a:r>
+              <a:rPr lang="en-US" dirty="0">
+                <a:latin typeface="Courier New" panose="02070309020205020404" pitchFamily="49" charset="0"/>
+                <a:cs typeface="Courier New" panose="02070309020205020404" pitchFamily="49" charset="0"/>
+              </a:rPr>
+              <a:t>pip install </a:t>
+            </a:r>
+            <a:r>
+              <a:rPr lang="en-US" dirty="0" err="1">
+                <a:latin typeface="Courier New" panose="02070309020205020404" pitchFamily="49" charset="0"/>
+                <a:cs typeface="Courier New" panose="02070309020205020404" pitchFamily="49" charset="0"/>
+              </a:rPr>
+              <a:t>pytest</a:t>
+            </a:r>
+            <a:endParaRPr lang="en-US" dirty="0">
+              <a:latin typeface="Courier New" panose="02070309020205020404" pitchFamily="49" charset="0"/>
+              <a:cs typeface="Courier New" panose="02070309020205020404" pitchFamily="49" charset="0"/>
+            </a:endParaRPr>
+          </a:p>
+          <a:p>
+            <a:pPr marL="0" indent="0">
+              <a:buNone/>
+            </a:pPr>
+            <a:r>
+              <a:rPr lang="en-US" dirty="0">
+                <a:latin typeface="Courier New" panose="02070309020205020404" pitchFamily="49" charset="0"/>
+                <a:cs typeface="Courier New" panose="02070309020205020404" pitchFamily="49" charset="0"/>
+              </a:rPr>
+              <a:t>pip install </a:t>
+            </a:r>
+            <a:r>
+              <a:rPr lang="en-US" dirty="0" err="1">
+                <a:latin typeface="Courier New" panose="02070309020205020404" pitchFamily="49" charset="0"/>
+                <a:cs typeface="Courier New" panose="02070309020205020404" pitchFamily="49" charset="0"/>
+              </a:rPr>
+              <a:t>pytest-cov</a:t>
+            </a:r>
+            <a:endParaRPr lang="en-US" dirty="0">
+              <a:latin typeface="Courier New" panose="02070309020205020404" pitchFamily="49" charset="0"/>
+              <a:cs typeface="Courier New" panose="02070309020205020404" pitchFamily="49" charset="0"/>
+            </a:endParaRPr>
+          </a:p>
+          <a:p>
+            <a:pPr marL="0" indent="0">
+              <a:buNone/>
+            </a:pPr>
+            <a:endParaRPr lang="en-US" dirty="0">
+              <a:latin typeface="Courier New" panose="02070309020205020404" pitchFamily="49" charset="0"/>
+              <a:cs typeface="Courier New" panose="02070309020205020404" pitchFamily="49" charset="0"/>
+            </a:endParaRPr>
+          </a:p>
+          <a:p>
+            <a:endParaRPr lang="en-US" dirty="0"/>
+          </a:p>
         </p:txBody>
       </p:sp>
       <p:sp>
@@ -24685,7 +24814,7 @@
           <a:p>
             <a:fld id="{334F72C3-CDF3-44A8-B602-1649B1728485}" type="datetime3">
               <a:rPr lang="en-US" smtClean="0"/>
-              <a:t>15 June 2026</a:t>
+              <a:t>16 June 2026</a:t>
             </a:fld>
             <a:endParaRPr lang="en-US"/>
           </a:p>
@@ -25913,7 +26042,7 @@
           <a:p>
             <a:fld id="{334F72C3-CDF3-44A8-B602-1649B1728485}" type="datetime3">
               <a:rPr lang="en-US" smtClean="0"/>
-              <a:t>15 June 2026</a:t>
+              <a:t>16 June 2026</a:t>
             </a:fld>
             <a:endParaRPr lang="en-US"/>
           </a:p>
@@ -26227,7 +26356,7 @@
           <a:p>
             <a:fld id="{334F72C3-CDF3-44A8-B602-1649B1728485}" type="datetime3">
               <a:rPr lang="en-US" smtClean="0"/>
-              <a:t>15 June 2026</a:t>
+              <a:t>16 June 2026</a:t>
             </a:fld>
             <a:endParaRPr lang="en-US"/>
           </a:p>
@@ -26298,15 +26427,15 @@
           <p:cNvPr id="2" name="Title 1">
             <a:extLst>
               <a:ext uri="{FF2B5EF4-FFF2-40B4-BE49-F238E27FC236}">
-                <a16:creationId xmlns:a16="http://schemas.microsoft.com/office/drawing/2014/main" id="{FE6EF007-C706-BB88-CA9D-5A0EA65F4E12}"/>
-              </a:ext>
-            </a:extLst>
-          </p:cNvPr>
-          <p:cNvSpPr>
-            <a:spLocks noGrp="1"/>
-          </p:cNvSpPr>
-          <p:nvPr>
-            <p:ph type="title"/>
+                <a16:creationId xmlns:a16="http://schemas.microsoft.com/office/drawing/2014/main" id="{B1D45B60-B1FC-1506-689D-7DD83D203EF3}"/>
+              </a:ext>
+            </a:extLst>
+          </p:cNvPr>
+          <p:cNvSpPr>
+            <a:spLocks noGrp="1"/>
+          </p:cNvSpPr>
+          <p:nvPr>
+            <p:ph type="ctrTitle"/>
           </p:nvPr>
         </p:nvSpPr>
         <p:spPr/>
@@ -26316,25 +26445,25 @@
           <a:p>
             <a:r>
               <a:rPr lang="en-US" dirty="0"/>
-              <a:t>Completeness</a:t>
-            </a:r>
-          </a:p>
-        </p:txBody>
-      </p:sp>
-      <p:sp>
-        <p:nvSpPr>
-          <p:cNvPr id="3" name="Content Placeholder 2">
-            <a:extLst>
-              <a:ext uri="{FF2B5EF4-FFF2-40B4-BE49-F238E27FC236}">
-                <a16:creationId xmlns:a16="http://schemas.microsoft.com/office/drawing/2014/main" id="{2CA2369A-5286-95C3-F1B1-37C71A7209E3}"/>
-              </a:ext>
-            </a:extLst>
-          </p:cNvPr>
-          <p:cNvSpPr>
-            <a:spLocks noGrp="1"/>
-          </p:cNvSpPr>
-          <p:nvPr>
-            <p:ph idx="1"/>
+              <a:t>Other Testing Ideas</a:t>
+            </a:r>
+          </a:p>
+        </p:txBody>
+      </p:sp>
+      <p:sp>
+        <p:nvSpPr>
+          <p:cNvPr id="3" name="Subtitle 2">
+            <a:extLst>
+              <a:ext uri="{FF2B5EF4-FFF2-40B4-BE49-F238E27FC236}">
+                <a16:creationId xmlns:a16="http://schemas.microsoft.com/office/drawing/2014/main" id="{B74F8CC1-46D5-FCBF-6034-9F91BA4A2E0B}"/>
+              </a:ext>
+            </a:extLst>
+          </p:cNvPr>
+          <p:cNvSpPr>
+            <a:spLocks noGrp="1"/>
+          </p:cNvSpPr>
+          <p:nvPr>
+            <p:ph type="subTitle" idx="1"/>
           </p:nvPr>
         </p:nvSpPr>
         <p:spPr/>
@@ -26342,10 +26471,7 @@
           <a:bodyPr/>
           <a:lstStyle/>
           <a:p>
-            <a:r>
-              <a:rPr lang="en-US" dirty="0"/>
-              <a:t>Code coverage</a:t>
-            </a:r>
+            <a:endParaRPr lang="en-US"/>
           </a:p>
         </p:txBody>
       </p:sp>
@@ -26354,15 +26480,15 @@
           <p:cNvPr id="4" name="Date Placeholder 3">
             <a:extLst>
               <a:ext uri="{FF2B5EF4-FFF2-40B4-BE49-F238E27FC236}">
-                <a16:creationId xmlns:a16="http://schemas.microsoft.com/office/drawing/2014/main" id="{55496368-EE73-EDD4-A570-E1B8AEC19887}"/>
-              </a:ext>
-            </a:extLst>
-          </p:cNvPr>
-          <p:cNvSpPr>
-            <a:spLocks noGrp="1"/>
-          </p:cNvSpPr>
-          <p:nvPr>
-            <p:ph type="dt" sz="half" idx="10"/>
+                <a16:creationId xmlns:a16="http://schemas.microsoft.com/office/drawing/2014/main" id="{C0933342-5FB8-2795-34ED-1344FFF14F69}"/>
+              </a:ext>
+            </a:extLst>
+          </p:cNvPr>
+          <p:cNvSpPr>
+            <a:spLocks noGrp="1"/>
+          </p:cNvSpPr>
+          <p:nvPr>
+            <p:ph type="dt" idx="10"/>
           </p:nvPr>
         </p:nvSpPr>
         <p:spPr/>
@@ -26370,28 +26496,24 @@
           <a:bodyPr/>
           <a:lstStyle/>
           <a:p>
-            <a:fld id="{AD622D1A-DF83-41A8-85FF-04D90BF831D3}" type="datetime3">
-              <a:rPr lang="en-US" smtClean="0"/>
-              <a:t>15 June 2026</a:t>
-            </a:fld>
             <a:endParaRPr lang="en-US"/>
           </a:p>
         </p:txBody>
       </p:sp>
       <p:sp>
         <p:nvSpPr>
-          <p:cNvPr id="5" name="Slide Number Placeholder 4">
-            <a:extLst>
-              <a:ext uri="{FF2B5EF4-FFF2-40B4-BE49-F238E27FC236}">
-                <a16:creationId xmlns:a16="http://schemas.microsoft.com/office/drawing/2014/main" id="{72FEC8BB-A300-E137-E2BE-5D5200542B7E}"/>
-              </a:ext>
-            </a:extLst>
-          </p:cNvPr>
-          <p:cNvSpPr>
-            <a:spLocks noGrp="1"/>
-          </p:cNvSpPr>
-          <p:nvPr>
-            <p:ph type="sldNum" sz="quarter" idx="11"/>
+          <p:cNvPr id="5" name="Footer Placeholder 4">
+            <a:extLst>
+              <a:ext uri="{FF2B5EF4-FFF2-40B4-BE49-F238E27FC236}">
+                <a16:creationId xmlns:a16="http://schemas.microsoft.com/office/drawing/2014/main" id="{AFCF829A-691A-9257-36A0-7F2B973054C5}"/>
+              </a:ext>
+            </a:extLst>
+          </p:cNvPr>
+          <p:cNvSpPr>
+            <a:spLocks noGrp="1"/>
+          </p:cNvSpPr>
+          <p:nvPr>
+            <p:ph type="ftr" idx="11"/>
           </p:nvPr>
         </p:nvSpPr>
         <p:spPr/>
@@ -26399,19 +26521,52 @@
           <a:bodyPr/>
           <a:lstStyle/>
           <a:p>
-            <a:fld id="{64E5BE4B-2FBF-4174-9E62-85FAD1CB43A6}" type="slidenum">
-              <a:rPr lang="en-US" smtClean="0"/>
-              <a:pPr/>
+            <a:endParaRPr lang="en-US"/>
+          </a:p>
+        </p:txBody>
+      </p:sp>
+      <p:sp>
+        <p:nvSpPr>
+          <p:cNvPr id="6" name="Slide Number Placeholder 5">
+            <a:extLst>
+              <a:ext uri="{FF2B5EF4-FFF2-40B4-BE49-F238E27FC236}">
+                <a16:creationId xmlns:a16="http://schemas.microsoft.com/office/drawing/2014/main" id="{71D8CD09-B708-C8FB-296A-F234E37A1C34}"/>
+              </a:ext>
+            </a:extLst>
+          </p:cNvPr>
+          <p:cNvSpPr>
+            <a:spLocks noGrp="1"/>
+          </p:cNvSpPr>
+          <p:nvPr>
+            <p:ph type="sldNum" idx="12"/>
+          </p:nvPr>
+        </p:nvSpPr>
+        <p:spPr/>
+        <p:txBody>
+          <a:bodyPr/>
+          <a:lstStyle/>
+          <a:p>
+            <a:pPr marL="0" lvl="0" indent="0" algn="r" rtl="0">
+              <a:spcBef>
+                <a:spcPts val="0"/>
+              </a:spcBef>
+              <a:spcAft>
+                <a:spcPts val="0"/>
+              </a:spcAft>
+              <a:buNone/>
+            </a:pPr>
+            <a:fld id="{00000000-1234-1234-1234-123412341234}" type="slidenum">
+              <a:rPr lang="en" smtClean="0"/>
               <a:t>14</a:t>
             </a:fld>
-            <a:endParaRPr lang="en-US"/>
+            <a:endParaRPr lang="en"/>
           </a:p>
         </p:txBody>
       </p:sp>
     </p:spTree>
     <p:extLst>
       <p:ext uri="{BB962C8B-B14F-4D97-AF65-F5344CB8AC3E}">
-        <p14:creationId xmlns:p14="http://schemas.microsoft.com/office/powerpoint/2010/main" val="3576461282"/>
+        <p14:creationId xmlns:p14="http://schemas.microsoft.com/office/powerpoint/2010/main" val="3973682615"/>
       </p:ext>
     </p:extLst>
   </p:cSld>
@@ -26443,7 +26598,7 @@
           <p:cNvPr id="2" name="Title 1">
             <a:extLst>
               <a:ext uri="{FF2B5EF4-FFF2-40B4-BE49-F238E27FC236}">
-                <a16:creationId xmlns:a16="http://schemas.microsoft.com/office/drawing/2014/main" id="{AFBE7449-8A14-8E4E-1773-68687CF077E7}"/>
+                <a16:creationId xmlns:a16="http://schemas.microsoft.com/office/drawing/2014/main" id="{FE6EF007-C706-BB88-CA9D-5A0EA65F4E12}"/>
               </a:ext>
             </a:extLst>
           </p:cNvPr>
@@ -26461,7 +26616,7 @@
           <a:p>
             <a:r>
               <a:rPr lang="en-US" dirty="0"/>
-              <a:t>DRY</a:t>
+              <a:t>Completeness</a:t>
             </a:r>
           </a:p>
         </p:txBody>
@@ -26471,7 +26626,7 @@
           <p:cNvPr id="3" name="Content Placeholder 2">
             <a:extLst>
               <a:ext uri="{FF2B5EF4-FFF2-40B4-BE49-F238E27FC236}">
-                <a16:creationId xmlns:a16="http://schemas.microsoft.com/office/drawing/2014/main" id="{85EFD7A7-318A-9FEF-28C1-5F14AE540E72}"/>
+                <a16:creationId xmlns:a16="http://schemas.microsoft.com/office/drawing/2014/main" id="{2CA2369A-5286-95C3-F1B1-37C71A7209E3}"/>
               </a:ext>
             </a:extLst>
           </p:cNvPr>
@@ -26489,8 +26644,29 @@
           <a:p>
             <a:r>
               <a:rPr lang="en-US" dirty="0"/>
-              <a:t>Fixtures</a:t>
-            </a:r>
+              <a:t>Control flow statements create branches</a:t>
+            </a:r>
+          </a:p>
+          <a:p>
+            <a:r>
+              <a:rPr lang="en-US" dirty="0"/>
+              <a:t>Are we covering every branch?</a:t>
+            </a:r>
+          </a:p>
+          <a:p>
+            <a:endParaRPr lang="en-US" dirty="0"/>
+          </a:p>
+          <a:p>
+            <a:endParaRPr lang="en-US" dirty="0"/>
+          </a:p>
+          <a:p>
+            <a:r>
+              <a:rPr lang="en-US" dirty="0"/>
+              <a:t>How much coverage is appropriate?</a:t>
+            </a:r>
+          </a:p>
+          <a:p>
+            <a:endParaRPr lang="en-US" dirty="0"/>
           </a:p>
         </p:txBody>
       </p:sp>
@@ -26499,7 +26675,7 @@
           <p:cNvPr id="4" name="Date Placeholder 3">
             <a:extLst>
               <a:ext uri="{FF2B5EF4-FFF2-40B4-BE49-F238E27FC236}">
-                <a16:creationId xmlns:a16="http://schemas.microsoft.com/office/drawing/2014/main" id="{8B55FC9A-DC16-0D9D-1583-AC865242E328}"/>
+                <a16:creationId xmlns:a16="http://schemas.microsoft.com/office/drawing/2014/main" id="{55496368-EE73-EDD4-A570-E1B8AEC19887}"/>
               </a:ext>
             </a:extLst>
           </p:cNvPr>
@@ -26517,7 +26693,7 @@
           <a:p>
             <a:fld id="{AD622D1A-DF83-41A8-85FF-04D90BF831D3}" type="datetime3">
               <a:rPr lang="en-US" smtClean="0"/>
-              <a:t>15 June 2026</a:t>
+              <a:t>16 June 2026</a:t>
             </a:fld>
             <a:endParaRPr lang="en-US"/>
           </a:p>
@@ -26528,7 +26704,7 @@
           <p:cNvPr id="5" name="Slide Number Placeholder 4">
             <a:extLst>
               <a:ext uri="{FF2B5EF4-FFF2-40B4-BE49-F238E27FC236}">
-                <a16:creationId xmlns:a16="http://schemas.microsoft.com/office/drawing/2014/main" id="{DB08E3C8-C147-89EA-F9F4-7977B79D869D}"/>
+                <a16:creationId xmlns:a16="http://schemas.microsoft.com/office/drawing/2014/main" id="{72FEC8BB-A300-E137-E2BE-5D5200542B7E}"/>
               </a:ext>
             </a:extLst>
           </p:cNvPr>
@@ -26556,13 +26732,92 @@
     </p:spTree>
     <p:extLst>
       <p:ext uri="{BB962C8B-B14F-4D97-AF65-F5344CB8AC3E}">
-        <p14:creationId xmlns:p14="http://schemas.microsoft.com/office/powerpoint/2010/main" val="1953408799"/>
+        <p14:creationId xmlns:p14="http://schemas.microsoft.com/office/powerpoint/2010/main" val="3576461282"/>
       </p:ext>
     </p:extLst>
   </p:cSld>
   <p:clrMapOvr>
     <a:masterClrMapping/>
   </p:clrMapOvr>
+  <p:timing>
+    <p:tnLst>
+      <p:par>
+        <p:cTn id="1" dur="indefinite" restart="never" nodeType="tmRoot">
+          <p:childTnLst>
+            <p:seq concurrent="1" nextAc="seek">
+              <p:cTn id="2" dur="indefinite" nodeType="mainSeq">
+                <p:childTnLst>
+                  <p:par>
+                    <p:cTn id="3" fill="hold">
+                      <p:stCondLst>
+                        <p:cond delay="indefinite"/>
+                      </p:stCondLst>
+                      <p:childTnLst>
+                        <p:par>
+                          <p:cTn id="4" fill="hold">
+                            <p:stCondLst>
+                              <p:cond delay="0"/>
+                            </p:stCondLst>
+                            <p:childTnLst>
+                              <p:par>
+                                <p:cTn id="5" presetID="1" presetClass="entr" presetSubtype="0" fill="hold" nodeType="clickEffect">
+                                  <p:stCondLst>
+                                    <p:cond delay="0"/>
+                                  </p:stCondLst>
+                                  <p:childTnLst>
+                                    <p:set>
+                                      <p:cBhvr>
+                                        <p:cTn id="6" dur="1" fill="hold">
+                                          <p:stCondLst>
+                                            <p:cond delay="0"/>
+                                          </p:stCondLst>
+                                        </p:cTn>
+                                        <p:tgtEl>
+                                          <p:spTgt spid="3">
+                                            <p:txEl>
+                                              <p:pRg st="4" end="4"/>
+                                            </p:txEl>
+                                          </p:spTgt>
+                                        </p:tgtEl>
+                                        <p:attrNameLst>
+                                          <p:attrName>style.visibility</p:attrName>
+                                        </p:attrNameLst>
+                                      </p:cBhvr>
+                                      <p:to>
+                                        <p:strVal val="visible"/>
+                                      </p:to>
+                                    </p:set>
+                                  </p:childTnLst>
+                                </p:cTn>
+                              </p:par>
+                            </p:childTnLst>
+                          </p:cTn>
+                        </p:par>
+                      </p:childTnLst>
+                    </p:cTn>
+                  </p:par>
+                </p:childTnLst>
+              </p:cTn>
+              <p:prevCondLst>
+                <p:cond evt="onPrev" delay="0">
+                  <p:tgtEl>
+                    <p:sldTgt/>
+                  </p:tgtEl>
+                </p:cond>
+              </p:prevCondLst>
+              <p:nextCondLst>
+                <p:cond evt="onNext" delay="0">
+                  <p:tgtEl>
+                    <p:sldTgt/>
+                  </p:tgtEl>
+                </p:cond>
+              </p:nextCondLst>
+            </p:seq>
+          </p:childTnLst>
+        </p:cTn>
+      </p:par>
+    </p:tnLst>
+  </p:timing>
 </p:sld>
 </file>
 
@@ -26588,7 +26843,7 @@
           <p:cNvPr id="2" name="Title 1">
             <a:extLst>
               <a:ext uri="{FF2B5EF4-FFF2-40B4-BE49-F238E27FC236}">
-                <a16:creationId xmlns:a16="http://schemas.microsoft.com/office/drawing/2014/main" id="{1E90BFE8-BEA7-3940-667B-3FF6A7BCDE23}"/>
+                <a16:creationId xmlns:a16="http://schemas.microsoft.com/office/drawing/2014/main" id="{54D0A327-E0F2-27C7-00A9-4C62F0E322C2}"/>
               </a:ext>
             </a:extLst>
           </p:cNvPr>
@@ -26606,30 +26861,57 @@
           <a:p>
             <a:r>
               <a:rPr lang="en-US" dirty="0"/>
-              <a:t>Mocking </a:t>
-            </a:r>
-            <a:r>
-              <a:rPr lang="en-US"/>
-              <a:t>External References</a:t>
-            </a:r>
-            <a:endParaRPr lang="en-US" dirty="0"/>
-          </a:p>
-        </p:txBody>
-      </p:sp>
-      <p:sp>
-        <p:nvSpPr>
-          <p:cNvPr id="3" name="Content Placeholder 2">
-            <a:extLst>
-              <a:ext uri="{FF2B5EF4-FFF2-40B4-BE49-F238E27FC236}">
-                <a16:creationId xmlns:a16="http://schemas.microsoft.com/office/drawing/2014/main" id="{3DFA01B0-9D70-8BBB-8D34-48A2E2EF3701}"/>
-              </a:ext>
-            </a:extLst>
-          </p:cNvPr>
-          <p:cNvSpPr>
-            <a:spLocks noGrp="1"/>
-          </p:cNvSpPr>
-          <p:nvPr>
-            <p:ph idx="1"/>
+              <a:t>Small Example</a:t>
+            </a:r>
+          </a:p>
+        </p:txBody>
+      </p:sp>
+      <p:pic>
+        <p:nvPicPr>
+          <p:cNvPr id="10" name="Content Placeholder 9">
+            <a:extLst>
+              <a:ext uri="{FF2B5EF4-FFF2-40B4-BE49-F238E27FC236}">
+                <a16:creationId xmlns:a16="http://schemas.microsoft.com/office/drawing/2014/main" id="{215EBD69-E5F4-0337-03B7-1432402A4082}"/>
+              </a:ext>
+            </a:extLst>
+          </p:cNvPr>
+          <p:cNvPicPr>
+            <a:picLocks noGrp="1" noChangeAspect="1"/>
+          </p:cNvPicPr>
+          <p:nvPr>
+            <p:ph sz="half" idx="2"/>
+          </p:nvPr>
+        </p:nvPicPr>
+        <p:blipFill>
+          <a:blip r:embed="rId2"/>
+          <a:stretch>
+            <a:fillRect/>
+          </a:stretch>
+        </p:blipFill>
+        <p:spPr>
+          <a:xfrm>
+            <a:off x="4660949" y="994411"/>
+            <a:ext cx="3627890" cy="2022629"/>
+          </a:xfrm>
+          <a:prstGeom prst="rect">
+            <a:avLst/>
+          </a:prstGeom>
+        </p:spPr>
+      </p:pic>
+      <p:sp>
+        <p:nvSpPr>
+          <p:cNvPr id="5" name="Date Placeholder 4">
+            <a:extLst>
+              <a:ext uri="{FF2B5EF4-FFF2-40B4-BE49-F238E27FC236}">
+                <a16:creationId xmlns:a16="http://schemas.microsoft.com/office/drawing/2014/main" id="{95D208E6-5131-B36E-0FBC-26BEEA0B8F5F}"/>
+              </a:ext>
+            </a:extLst>
+          </p:cNvPr>
+          <p:cNvSpPr>
+            <a:spLocks noGrp="1"/>
+          </p:cNvSpPr>
+          <p:nvPr>
+            <p:ph type="dt" sz="half" idx="10"/>
           </p:nvPr>
         </p:nvSpPr>
         <p:spPr/>
@@ -26637,37 +26919,9 @@
           <a:bodyPr/>
           <a:lstStyle/>
           <a:p>
-            <a:r>
-              <a:rPr lang="en-US" dirty="0"/>
-              <a:t>Intro to mocks</a:t>
-            </a:r>
-          </a:p>
-        </p:txBody>
-      </p:sp>
-      <p:sp>
-        <p:nvSpPr>
-          <p:cNvPr id="4" name="Date Placeholder 3">
-            <a:extLst>
-              <a:ext uri="{FF2B5EF4-FFF2-40B4-BE49-F238E27FC236}">
-                <a16:creationId xmlns:a16="http://schemas.microsoft.com/office/drawing/2014/main" id="{4FFB9305-2CBA-FCFF-86FC-1A2D6F2DCA86}"/>
-              </a:ext>
-            </a:extLst>
-          </p:cNvPr>
-          <p:cNvSpPr>
-            <a:spLocks noGrp="1"/>
-          </p:cNvSpPr>
-          <p:nvPr>
-            <p:ph type="dt" sz="half" idx="10"/>
-          </p:nvPr>
-        </p:nvSpPr>
-        <p:spPr/>
-        <p:txBody>
-          <a:bodyPr/>
-          <a:lstStyle/>
-          <a:p>
-            <a:fld id="{AD622D1A-DF83-41A8-85FF-04D90BF831D3}" type="datetime3">
+            <a:fld id="{334F72C3-CDF3-44A8-B602-1649B1728485}" type="datetime3">
               <a:rPr lang="en-US" smtClean="0"/>
-              <a:t>15 June 2026</a:t>
+              <a:t>16 June 2026</a:t>
             </a:fld>
             <a:endParaRPr lang="en-US"/>
           </a:p>
@@ -26675,10 +26929,10 @@
       </p:sp>
       <p:sp>
         <p:nvSpPr>
-          <p:cNvPr id="5" name="Slide Number Placeholder 4">
-            <a:extLst>
-              <a:ext uri="{FF2B5EF4-FFF2-40B4-BE49-F238E27FC236}">
-                <a16:creationId xmlns:a16="http://schemas.microsoft.com/office/drawing/2014/main" id="{BC24ECD0-6721-C76E-C7B4-37CC4871FADC}"/>
+          <p:cNvPr id="6" name="Slide Number Placeholder 5">
+            <a:extLst>
+              <a:ext uri="{FF2B5EF4-FFF2-40B4-BE49-F238E27FC236}">
+                <a16:creationId xmlns:a16="http://schemas.microsoft.com/office/drawing/2014/main" id="{7426B6D3-6F8D-0CE5-ECBB-04D8DDF141B3}"/>
               </a:ext>
             </a:extLst>
           </p:cNvPr>
@@ -26703,16 +26957,599 @@
           </a:p>
         </p:txBody>
       </p:sp>
+      <p:sp>
+        <p:nvSpPr>
+          <p:cNvPr id="8" name="TextBox 7">
+            <a:extLst>
+              <a:ext uri="{FF2B5EF4-FFF2-40B4-BE49-F238E27FC236}">
+                <a16:creationId xmlns:a16="http://schemas.microsoft.com/office/drawing/2014/main" id="{55AA7033-21A9-9E57-A2BD-B6A206D7AF02}"/>
+              </a:ext>
+            </a:extLst>
+          </p:cNvPr>
+          <p:cNvSpPr txBox="1"/>
+          <p:nvPr/>
+        </p:nvSpPr>
+        <p:spPr>
+          <a:xfrm>
+            <a:off x="410766" y="1200150"/>
+            <a:ext cx="4572000" cy="2068515"/>
+          </a:xfrm>
+          <a:prstGeom prst="rect">
+            <a:avLst/>
+          </a:prstGeom>
+          <a:noFill/>
+        </p:spPr>
+        <p:txBody>
+          <a:bodyPr wrap="square">
+            <a:spAutoFit/>
+          </a:bodyPr>
+          <a:lstStyle/>
+          <a:p>
+            <a:pPr>
+              <a:lnSpc>
+                <a:spcPts val="1425"/>
+              </a:lnSpc>
+              <a:buNone/>
+            </a:pPr>
+            <a:r>
+              <a:rPr lang="en-US" b="0" dirty="0">
+                <a:solidFill>
+                  <a:srgbClr val="0000FF"/>
+                </a:solidFill>
+                <a:effectLst/>
+                <a:latin typeface="Consolas" panose="020B0609020204030204" pitchFamily="49" charset="0"/>
+              </a:rPr>
+              <a:t>def</a:t>
+            </a:r>
+            <a:r>
+              <a:rPr lang="en-US" b="0" dirty="0">
+                <a:solidFill>
+                  <a:srgbClr val="000000"/>
+                </a:solidFill>
+                <a:effectLst/>
+                <a:latin typeface="Consolas" panose="020B0609020204030204" pitchFamily="49" charset="0"/>
+              </a:rPr>
+              <a:t> </a:t>
+            </a:r>
+            <a:r>
+              <a:rPr lang="en-US" b="0" dirty="0" err="1">
+                <a:solidFill>
+                  <a:srgbClr val="795E26"/>
+                </a:solidFill>
+                <a:effectLst/>
+                <a:latin typeface="Consolas" panose="020B0609020204030204" pitchFamily="49" charset="0"/>
+              </a:rPr>
+              <a:t>absolute_value</a:t>
+            </a:r>
+            <a:r>
+              <a:rPr lang="en-US" b="0" dirty="0">
+                <a:solidFill>
+                  <a:srgbClr val="000000"/>
+                </a:solidFill>
+                <a:effectLst/>
+                <a:latin typeface="Consolas" panose="020B0609020204030204" pitchFamily="49" charset="0"/>
+              </a:rPr>
+              <a:t>(</a:t>
+            </a:r>
+            <a:r>
+              <a:rPr lang="en-US" b="0" dirty="0">
+                <a:solidFill>
+                  <a:srgbClr val="001080"/>
+                </a:solidFill>
+                <a:effectLst/>
+                <a:latin typeface="Consolas" panose="020B0609020204030204" pitchFamily="49" charset="0"/>
+              </a:rPr>
+              <a:t>num</a:t>
+            </a:r>
+            <a:r>
+              <a:rPr lang="en-US" b="0" dirty="0">
+                <a:solidFill>
+                  <a:srgbClr val="000000"/>
+                </a:solidFill>
+                <a:effectLst/>
+                <a:latin typeface="Consolas" panose="020B0609020204030204" pitchFamily="49" charset="0"/>
+              </a:rPr>
+              <a:t>: </a:t>
+            </a:r>
+            <a:r>
+              <a:rPr lang="en-US" b="0" dirty="0">
+                <a:solidFill>
+                  <a:srgbClr val="267F99"/>
+                </a:solidFill>
+                <a:effectLst/>
+                <a:latin typeface="Consolas" panose="020B0609020204030204" pitchFamily="49" charset="0"/>
+              </a:rPr>
+              <a:t>int</a:t>
+            </a:r>
+            <a:r>
+              <a:rPr lang="en-US" b="0" dirty="0">
+                <a:solidFill>
+                  <a:srgbClr val="000000"/>
+                </a:solidFill>
+                <a:effectLst/>
+                <a:latin typeface="Consolas" panose="020B0609020204030204" pitchFamily="49" charset="0"/>
+              </a:rPr>
+              <a:t>) -&gt; </a:t>
+            </a:r>
+            <a:r>
+              <a:rPr lang="en-US" b="0" dirty="0">
+                <a:solidFill>
+                  <a:srgbClr val="267F99"/>
+                </a:solidFill>
+                <a:effectLst/>
+                <a:latin typeface="Consolas" panose="020B0609020204030204" pitchFamily="49" charset="0"/>
+              </a:rPr>
+              <a:t>int</a:t>
+            </a:r>
+            <a:r>
+              <a:rPr lang="en-US" b="0" dirty="0">
+                <a:solidFill>
+                  <a:srgbClr val="000000"/>
+                </a:solidFill>
+                <a:effectLst/>
+                <a:latin typeface="Consolas" panose="020B0609020204030204" pitchFamily="49" charset="0"/>
+              </a:rPr>
+              <a:t>:</a:t>
+            </a:r>
+          </a:p>
+          <a:p>
+            <a:pPr>
+              <a:lnSpc>
+                <a:spcPts val="1425"/>
+              </a:lnSpc>
+              <a:buNone/>
+            </a:pPr>
+            <a:r>
+              <a:rPr lang="en-US" b="0" dirty="0">
+                <a:solidFill>
+                  <a:srgbClr val="000000"/>
+                </a:solidFill>
+                <a:effectLst/>
+                <a:latin typeface="Consolas" panose="020B0609020204030204" pitchFamily="49" charset="0"/>
+              </a:rPr>
+              <a:t>    </a:t>
+            </a:r>
+            <a:r>
+              <a:rPr lang="en-US" b="0" dirty="0">
+                <a:solidFill>
+                  <a:srgbClr val="AF00DB"/>
+                </a:solidFill>
+                <a:effectLst/>
+                <a:latin typeface="Consolas" panose="020B0609020204030204" pitchFamily="49" charset="0"/>
+              </a:rPr>
+              <a:t>if</a:t>
+            </a:r>
+            <a:r>
+              <a:rPr lang="en-US" b="0" dirty="0">
+                <a:solidFill>
+                  <a:srgbClr val="000000"/>
+                </a:solidFill>
+                <a:effectLst/>
+                <a:latin typeface="Consolas" panose="020B0609020204030204" pitchFamily="49" charset="0"/>
+              </a:rPr>
+              <a:t> </a:t>
+            </a:r>
+            <a:r>
+              <a:rPr lang="en-US" b="0" dirty="0">
+                <a:solidFill>
+                  <a:srgbClr val="001080"/>
+                </a:solidFill>
+                <a:effectLst/>
+                <a:latin typeface="Consolas" panose="020B0609020204030204" pitchFamily="49" charset="0"/>
+              </a:rPr>
+              <a:t>num</a:t>
+            </a:r>
+            <a:r>
+              <a:rPr lang="en-US" b="0" dirty="0">
+                <a:solidFill>
+                  <a:srgbClr val="000000"/>
+                </a:solidFill>
+                <a:effectLst/>
+                <a:latin typeface="Consolas" panose="020B0609020204030204" pitchFamily="49" charset="0"/>
+              </a:rPr>
+              <a:t> &lt; </a:t>
+            </a:r>
+            <a:r>
+              <a:rPr lang="en-US" b="0" dirty="0">
+                <a:solidFill>
+                  <a:srgbClr val="098658"/>
+                </a:solidFill>
+                <a:effectLst/>
+                <a:latin typeface="Consolas" panose="020B0609020204030204" pitchFamily="49" charset="0"/>
+              </a:rPr>
+              <a:t>0</a:t>
+            </a:r>
+            <a:r>
+              <a:rPr lang="en-US" b="0" dirty="0">
+                <a:solidFill>
+                  <a:srgbClr val="000000"/>
+                </a:solidFill>
+                <a:effectLst/>
+                <a:latin typeface="Consolas" panose="020B0609020204030204" pitchFamily="49" charset="0"/>
+              </a:rPr>
+              <a:t>:</a:t>
+            </a:r>
+          </a:p>
+          <a:p>
+            <a:pPr>
+              <a:lnSpc>
+                <a:spcPts val="1425"/>
+              </a:lnSpc>
+              <a:buNone/>
+            </a:pPr>
+            <a:r>
+              <a:rPr lang="en-US" b="0" dirty="0">
+                <a:solidFill>
+                  <a:srgbClr val="000000"/>
+                </a:solidFill>
+                <a:effectLst/>
+                <a:latin typeface="Consolas" panose="020B0609020204030204" pitchFamily="49" charset="0"/>
+              </a:rPr>
+              <a:t>        </a:t>
+            </a:r>
+            <a:r>
+              <a:rPr lang="en-US" b="0" dirty="0">
+                <a:solidFill>
+                  <a:srgbClr val="AF00DB"/>
+                </a:solidFill>
+                <a:effectLst/>
+                <a:latin typeface="Consolas" panose="020B0609020204030204" pitchFamily="49" charset="0"/>
+              </a:rPr>
+              <a:t>return</a:t>
+            </a:r>
+            <a:r>
+              <a:rPr lang="en-US" b="0" dirty="0">
+                <a:solidFill>
+                  <a:srgbClr val="000000"/>
+                </a:solidFill>
+                <a:effectLst/>
+                <a:latin typeface="Consolas" panose="020B0609020204030204" pitchFamily="49" charset="0"/>
+              </a:rPr>
+              <a:t> -</a:t>
+            </a:r>
+            <a:r>
+              <a:rPr lang="en-US" b="0" dirty="0">
+                <a:solidFill>
+                  <a:srgbClr val="001080"/>
+                </a:solidFill>
+                <a:effectLst/>
+                <a:latin typeface="Consolas" panose="020B0609020204030204" pitchFamily="49" charset="0"/>
+              </a:rPr>
+              <a:t>num</a:t>
+            </a:r>
+            <a:endParaRPr lang="en-US" b="0" dirty="0">
+              <a:solidFill>
+                <a:srgbClr val="000000"/>
+              </a:solidFill>
+              <a:effectLst/>
+              <a:latin typeface="Consolas" panose="020B0609020204030204" pitchFamily="49" charset="0"/>
+            </a:endParaRPr>
+          </a:p>
+          <a:p>
+            <a:pPr>
+              <a:lnSpc>
+                <a:spcPts val="1425"/>
+              </a:lnSpc>
+              <a:buNone/>
+            </a:pPr>
+            <a:r>
+              <a:rPr lang="en-US" b="0" dirty="0">
+                <a:solidFill>
+                  <a:srgbClr val="000000"/>
+                </a:solidFill>
+                <a:effectLst/>
+                <a:latin typeface="Consolas" panose="020B0609020204030204" pitchFamily="49" charset="0"/>
+              </a:rPr>
+              <a:t>    </a:t>
+            </a:r>
+            <a:r>
+              <a:rPr lang="en-US" b="0" dirty="0">
+                <a:solidFill>
+                  <a:srgbClr val="AF00DB"/>
+                </a:solidFill>
+                <a:effectLst/>
+                <a:latin typeface="Consolas" panose="020B0609020204030204" pitchFamily="49" charset="0"/>
+              </a:rPr>
+              <a:t>return</a:t>
+            </a:r>
+            <a:r>
+              <a:rPr lang="en-US" b="0" dirty="0">
+                <a:solidFill>
+                  <a:srgbClr val="000000"/>
+                </a:solidFill>
+                <a:effectLst/>
+                <a:latin typeface="Consolas" panose="020B0609020204030204" pitchFamily="49" charset="0"/>
+              </a:rPr>
+              <a:t> </a:t>
+            </a:r>
+            <a:r>
+              <a:rPr lang="en-US" b="0" dirty="0">
+                <a:solidFill>
+                  <a:srgbClr val="001080"/>
+                </a:solidFill>
+                <a:effectLst/>
+                <a:latin typeface="Consolas" panose="020B0609020204030204" pitchFamily="49" charset="0"/>
+              </a:rPr>
+              <a:t>num</a:t>
+            </a:r>
+            <a:endParaRPr lang="en-US" b="0" dirty="0">
+              <a:solidFill>
+                <a:srgbClr val="000000"/>
+              </a:solidFill>
+              <a:effectLst/>
+              <a:latin typeface="Consolas" panose="020B0609020204030204" pitchFamily="49" charset="0"/>
+            </a:endParaRPr>
+          </a:p>
+          <a:p>
+            <a:pPr>
+              <a:lnSpc>
+                <a:spcPts val="1425"/>
+              </a:lnSpc>
+              <a:buNone/>
+            </a:pPr>
+            <a:br>
+              <a:rPr lang="en-US" b="0" dirty="0">
+                <a:solidFill>
+                  <a:srgbClr val="000000"/>
+                </a:solidFill>
+                <a:effectLst/>
+                <a:latin typeface="Consolas" panose="020B0609020204030204" pitchFamily="49" charset="0"/>
+              </a:rPr>
+            </a:br>
+            <a:br>
+              <a:rPr lang="en-US" b="0" dirty="0">
+                <a:solidFill>
+                  <a:srgbClr val="000000"/>
+                </a:solidFill>
+                <a:effectLst/>
+                <a:latin typeface="Consolas" panose="020B0609020204030204" pitchFamily="49" charset="0"/>
+              </a:rPr>
+            </a:br>
+            <a:endParaRPr lang="en-US" b="0" dirty="0">
+              <a:solidFill>
+                <a:srgbClr val="000000"/>
+              </a:solidFill>
+              <a:effectLst/>
+              <a:latin typeface="Consolas" panose="020B0609020204030204" pitchFamily="49" charset="0"/>
+            </a:endParaRPr>
+          </a:p>
+          <a:p>
+            <a:pPr>
+              <a:lnSpc>
+                <a:spcPts val="1425"/>
+              </a:lnSpc>
+              <a:buNone/>
+            </a:pPr>
+            <a:r>
+              <a:rPr lang="en-US" b="0" dirty="0">
+                <a:solidFill>
+                  <a:srgbClr val="0000FF"/>
+                </a:solidFill>
+                <a:effectLst/>
+                <a:latin typeface="Consolas" panose="020B0609020204030204" pitchFamily="49" charset="0"/>
+              </a:rPr>
+              <a:t>def</a:t>
+            </a:r>
+            <a:r>
+              <a:rPr lang="en-US" b="0" dirty="0">
+                <a:solidFill>
+                  <a:srgbClr val="000000"/>
+                </a:solidFill>
+                <a:effectLst/>
+                <a:latin typeface="Consolas" panose="020B0609020204030204" pitchFamily="49" charset="0"/>
+              </a:rPr>
+              <a:t> </a:t>
+            </a:r>
+            <a:r>
+              <a:rPr lang="en-US" b="0" dirty="0" err="1">
+                <a:solidFill>
+                  <a:srgbClr val="795E26"/>
+                </a:solidFill>
+                <a:effectLst/>
+                <a:latin typeface="Consolas" panose="020B0609020204030204" pitchFamily="49" charset="0"/>
+              </a:rPr>
+              <a:t>test_absolute_value</a:t>
+            </a:r>
+            <a:r>
+              <a:rPr lang="en-US" b="0" dirty="0">
+                <a:solidFill>
+                  <a:srgbClr val="000000"/>
+                </a:solidFill>
+                <a:effectLst/>
+                <a:latin typeface="Consolas" panose="020B0609020204030204" pitchFamily="49" charset="0"/>
+              </a:rPr>
+              <a:t>():</a:t>
+            </a:r>
+          </a:p>
+          <a:p>
+            <a:pPr>
+              <a:lnSpc>
+                <a:spcPts val="1425"/>
+              </a:lnSpc>
+              <a:buNone/>
+            </a:pPr>
+            <a:r>
+              <a:rPr lang="en-US" b="0" dirty="0">
+                <a:solidFill>
+                  <a:srgbClr val="000000"/>
+                </a:solidFill>
+                <a:effectLst/>
+                <a:latin typeface="Consolas" panose="020B0609020204030204" pitchFamily="49" charset="0"/>
+              </a:rPr>
+              <a:t>    </a:t>
+            </a:r>
+            <a:r>
+              <a:rPr lang="en-US" b="0" dirty="0">
+                <a:solidFill>
+                  <a:srgbClr val="AF00DB"/>
+                </a:solidFill>
+                <a:effectLst/>
+                <a:latin typeface="Consolas" panose="020B0609020204030204" pitchFamily="49" charset="0"/>
+              </a:rPr>
+              <a:t>assert</a:t>
+            </a:r>
+            <a:r>
+              <a:rPr lang="en-US" b="0" dirty="0">
+                <a:solidFill>
+                  <a:srgbClr val="000000"/>
+                </a:solidFill>
+                <a:effectLst/>
+                <a:latin typeface="Consolas" panose="020B0609020204030204" pitchFamily="49" charset="0"/>
+              </a:rPr>
+              <a:t> </a:t>
+            </a:r>
+            <a:r>
+              <a:rPr lang="en-US" b="0" dirty="0" err="1">
+                <a:solidFill>
+                  <a:srgbClr val="795E26"/>
+                </a:solidFill>
+                <a:effectLst/>
+                <a:latin typeface="Consolas" panose="020B0609020204030204" pitchFamily="49" charset="0"/>
+              </a:rPr>
+              <a:t>absolute_value</a:t>
+            </a:r>
+            <a:r>
+              <a:rPr lang="en-US" b="0" dirty="0">
+                <a:solidFill>
+                  <a:srgbClr val="000000"/>
+                </a:solidFill>
+                <a:effectLst/>
+                <a:latin typeface="Consolas" panose="020B0609020204030204" pitchFamily="49" charset="0"/>
+              </a:rPr>
+              <a:t>(</a:t>
+            </a:r>
+            <a:r>
+              <a:rPr lang="en-US" b="0" dirty="0">
+                <a:solidFill>
+                  <a:srgbClr val="098658"/>
+                </a:solidFill>
+                <a:effectLst/>
+                <a:latin typeface="Consolas" panose="020B0609020204030204" pitchFamily="49" charset="0"/>
+              </a:rPr>
+              <a:t>5</a:t>
+            </a:r>
+            <a:r>
+              <a:rPr lang="en-US" b="0" dirty="0">
+                <a:solidFill>
+                  <a:srgbClr val="000000"/>
+                </a:solidFill>
+                <a:effectLst/>
+                <a:latin typeface="Consolas" panose="020B0609020204030204" pitchFamily="49" charset="0"/>
+              </a:rPr>
+              <a:t>)</a:t>
+            </a:r>
+          </a:p>
+          <a:p>
+            <a:pPr>
+              <a:lnSpc>
+                <a:spcPts val="1425"/>
+              </a:lnSpc>
+              <a:buNone/>
+            </a:pPr>
+            <a:br>
+              <a:rPr lang="en-US" b="0" dirty="0">
+                <a:solidFill>
+                  <a:srgbClr val="000000"/>
+                </a:solidFill>
+                <a:effectLst/>
+                <a:latin typeface="Consolas" panose="020B0609020204030204" pitchFamily="49" charset="0"/>
+              </a:rPr>
+            </a:br>
+            <a:endParaRPr lang="en-US" b="0" dirty="0">
+              <a:solidFill>
+                <a:srgbClr val="000000"/>
+              </a:solidFill>
+              <a:effectLst/>
+              <a:latin typeface="Consolas" panose="020B0609020204030204" pitchFamily="49" charset="0"/>
+            </a:endParaRPr>
+          </a:p>
+        </p:txBody>
+      </p:sp>
     </p:spTree>
     <p:extLst>
       <p:ext uri="{BB962C8B-B14F-4D97-AF65-F5344CB8AC3E}">
-        <p14:creationId xmlns:p14="http://schemas.microsoft.com/office/powerpoint/2010/main" val="1276382243"/>
+        <p14:creationId xmlns:p14="http://schemas.microsoft.com/office/powerpoint/2010/main" val="723051048"/>
       </p:ext>
     </p:extLst>
   </p:cSld>
   <p:clrMapOvr>
     <a:masterClrMapping/>
   </p:clrMapOvr>
+  <p:timing>
+    <p:tnLst>
+      <p:par>
+        <p:cTn id="1" dur="indefinite" restart="never" nodeType="tmRoot">
+          <p:childTnLst>
+            <p:seq concurrent="1" nextAc="seek">
+              <p:cTn id="2" dur="indefinite" nodeType="mainSeq">
+                <p:childTnLst>
+                  <p:par>
+                    <p:cTn id="3" fill="hold">
+                      <p:stCondLst>
+                        <p:cond delay="indefinite"/>
+                      </p:stCondLst>
+                      <p:childTnLst>
+                        <p:par>
+                          <p:cTn id="4" fill="hold">
+                            <p:stCondLst>
+                              <p:cond delay="0"/>
+                            </p:stCondLst>
+                            <p:childTnLst>
+                              <p:par>
+                                <p:cTn id="5" presetID="1" presetClass="entr" presetSubtype="0" fill="hold" nodeType="clickEffect">
+                                  <p:stCondLst>
+                                    <p:cond delay="0"/>
+                                  </p:stCondLst>
+                                  <p:childTnLst>
+                                    <p:set>
+                                      <p:cBhvr>
+                                        <p:cTn id="6" dur="1" fill="hold">
+                                          <p:stCondLst>
+                                            <p:cond delay="0"/>
+                                          </p:stCondLst>
+                                        </p:cTn>
+                                        <p:tgtEl>
+                                          <p:spTgt spid="10"/>
+                                        </p:tgtEl>
+                                        <p:attrNameLst>
+                                          <p:attrName>style.visibility</p:attrName>
+                                        </p:attrNameLst>
+                                      </p:cBhvr>
+                                      <p:to>
+                                        <p:strVal val="visible"/>
+                                      </p:to>
+                                    </p:set>
+                                  </p:childTnLst>
+                                </p:cTn>
+                              </p:par>
+                            </p:childTnLst>
+                          </p:cTn>
+                        </p:par>
+                      </p:childTnLst>
+                    </p:cTn>
+                  </p:par>
+                </p:childTnLst>
+              </p:cTn>
+              <p:prevCondLst>
+                <p:cond evt="onPrev" delay="0">
+                  <p:tgtEl>
+                    <p:sldTgt/>
+                  </p:tgtEl>
+                </p:cond>
+              </p:prevCondLst>
+              <p:nextCondLst>
+                <p:cond evt="onNext" delay="0">
+                  <p:tgtEl>
+                    <p:sldTgt/>
+                  </p:tgtEl>
+                </p:cond>
+              </p:nextCondLst>
+            </p:seq>
+          </p:childTnLst>
+        </p:cTn>
+      </p:par>
+    </p:tnLst>
+  </p:timing>
 </p:sld>
 </file>
 
@@ -26721,13 +27558,7 @@
   <p:cSld>
     <p:spTree>
       <p:nvGrpSpPr>
-        <p:cNvPr id="1" name="">
-          <a:extLst>
-            <a:ext uri="{FF2B5EF4-FFF2-40B4-BE49-F238E27FC236}">
-              <a16:creationId xmlns:a16="http://schemas.microsoft.com/office/drawing/2014/main" id="{324DADAD-76BA-9AB6-04D8-F96359438996}"/>
-            </a:ext>
-          </a:extLst>
-        </p:cNvPr>
+        <p:cNvPr id="1" name=""/>
         <p:cNvGrpSpPr/>
         <p:nvPr/>
       </p:nvGrpSpPr>
@@ -26741,18 +27572,18 @@
       </p:grpSpPr>
       <p:sp>
         <p:nvSpPr>
-          <p:cNvPr id="19" name="Title 18">
-            <a:extLst>
-              <a:ext uri="{FF2B5EF4-FFF2-40B4-BE49-F238E27FC236}">
-                <a16:creationId xmlns:a16="http://schemas.microsoft.com/office/drawing/2014/main" id="{36B38081-0A20-1671-69BB-F04D160E86DA}"/>
-              </a:ext>
-            </a:extLst>
-          </p:cNvPr>
-          <p:cNvSpPr>
-            <a:spLocks noGrp="1"/>
-          </p:cNvSpPr>
-          <p:nvPr>
-            <p:ph type="ctrTitle"/>
+          <p:cNvPr id="2" name="Title 1">
+            <a:extLst>
+              <a:ext uri="{FF2B5EF4-FFF2-40B4-BE49-F238E27FC236}">
+                <a16:creationId xmlns:a16="http://schemas.microsoft.com/office/drawing/2014/main" id="{A2F0144F-FE59-741D-2921-2ACD8FAC281B}"/>
+              </a:ext>
+            </a:extLst>
+          </p:cNvPr>
+          <p:cNvSpPr>
+            <a:spLocks noGrp="1"/>
+          </p:cNvSpPr>
+          <p:nvPr>
+            <p:ph type="title"/>
           </p:nvPr>
         </p:nvSpPr>
         <p:spPr/>
@@ -26762,50 +27593,154 @@
           <a:p>
             <a:r>
               <a:rPr lang="en-US" dirty="0"/>
-              <a:t>Integration Tests</a:t>
-            </a:r>
-          </a:p>
-        </p:txBody>
-      </p:sp>
-      <p:sp>
-        <p:nvSpPr>
-          <p:cNvPr id="20" name="Subtitle 19">
-            <a:extLst>
-              <a:ext uri="{FF2B5EF4-FFF2-40B4-BE49-F238E27FC236}">
-                <a16:creationId xmlns:a16="http://schemas.microsoft.com/office/drawing/2014/main" id="{3BA15F1A-B579-CF67-3060-C51EA22FB5C8}"/>
-              </a:ext>
-            </a:extLst>
-          </p:cNvPr>
-          <p:cNvSpPr>
-            <a:spLocks noGrp="1"/>
-          </p:cNvSpPr>
-          <p:nvPr>
-            <p:ph type="subTitle" idx="1"/>
-          </p:nvPr>
-        </p:nvSpPr>
-        <p:spPr/>
+              <a:t>Larger Example</a:t>
+            </a:r>
+          </a:p>
+        </p:txBody>
+      </p:sp>
+      <p:sp>
+        <p:nvSpPr>
+          <p:cNvPr id="3" name="Content Placeholder 2">
+            <a:extLst>
+              <a:ext uri="{FF2B5EF4-FFF2-40B4-BE49-F238E27FC236}">
+                <a16:creationId xmlns:a16="http://schemas.microsoft.com/office/drawing/2014/main" id="{15330220-1517-79DB-8E21-5278B36E44CB}"/>
+              </a:ext>
+            </a:extLst>
+          </p:cNvPr>
+          <p:cNvSpPr>
+            <a:spLocks noGrp="1"/>
+          </p:cNvSpPr>
+          <p:nvPr>
+            <p:ph sz="half" idx="1"/>
+          </p:nvPr>
+        </p:nvSpPr>
+        <p:spPr>
+          <a:xfrm>
+            <a:off x="264724" y="1200150"/>
+            <a:ext cx="4023360" cy="3429000"/>
+          </a:xfrm>
+        </p:spPr>
         <p:txBody>
           <a:bodyPr/>
           <a:lstStyle/>
           <a:p>
-            <a:endParaRPr lang="en-US"/>
-          </a:p>
-        </p:txBody>
-      </p:sp>
-      <p:sp>
-        <p:nvSpPr>
-          <p:cNvPr id="4" name="Date Placeholder 3">
-            <a:extLst>
-              <a:ext uri="{FF2B5EF4-FFF2-40B4-BE49-F238E27FC236}">
-                <a16:creationId xmlns:a16="http://schemas.microsoft.com/office/drawing/2014/main" id="{5EC030FD-2B80-BD4D-BA09-0A7A49C2BA76}"/>
-              </a:ext>
-            </a:extLst>
-          </p:cNvPr>
-          <p:cNvSpPr>
-            <a:spLocks noGrp="1"/>
-          </p:cNvSpPr>
-          <p:nvPr>
-            <p:ph type="dt" idx="10"/>
+            <a:r>
+              <a:rPr lang="en-US" dirty="0"/>
+              <a:t>Inventory class</a:t>
+            </a:r>
+          </a:p>
+          <a:p>
+            <a:pPr marL="0" indent="0">
+              <a:buNone/>
+            </a:pPr>
+            <a:r>
+              <a:rPr lang="en-US" dirty="0" err="1">
+                <a:latin typeface="Courier New" panose="02070309020205020404" pitchFamily="49" charset="0"/>
+                <a:cs typeface="Courier New" panose="02070309020205020404" pitchFamily="49" charset="0"/>
+              </a:rPr>
+              <a:t>pytest</a:t>
+            </a:r>
+            <a:r>
+              <a:rPr lang="en-US" dirty="0">
+                <a:latin typeface="Courier New" panose="02070309020205020404" pitchFamily="49" charset="0"/>
+                <a:cs typeface="Courier New" panose="02070309020205020404" pitchFamily="49" charset="0"/>
+              </a:rPr>
+              <a:t> --</a:t>
+            </a:r>
+            <a:r>
+              <a:rPr lang="en-US" dirty="0" err="1">
+                <a:latin typeface="Courier New" panose="02070309020205020404" pitchFamily="49" charset="0"/>
+                <a:cs typeface="Courier New" panose="02070309020205020404" pitchFamily="49" charset="0"/>
+              </a:rPr>
+              <a:t>cov</a:t>
+            </a:r>
+            <a:r>
+              <a:rPr lang="en-US" dirty="0">
+                <a:latin typeface="Courier New" panose="02070309020205020404" pitchFamily="49" charset="0"/>
+                <a:cs typeface="Courier New" panose="02070309020205020404" pitchFamily="49" charset="0"/>
+              </a:rPr>
+              <a:t>=inventory</a:t>
+            </a:r>
+            <a:br>
+              <a:rPr lang="en-US" dirty="0">
+                <a:latin typeface="Courier New" panose="02070309020205020404" pitchFamily="49" charset="0"/>
+                <a:cs typeface="Courier New" panose="02070309020205020404" pitchFamily="49" charset="0"/>
+              </a:rPr>
+            </a:br>
+            <a:r>
+              <a:rPr lang="en-US" dirty="0">
+                <a:latin typeface="Courier New" panose="02070309020205020404" pitchFamily="49" charset="0"/>
+                <a:cs typeface="Courier New" panose="02070309020205020404" pitchFamily="49" charset="0"/>
+              </a:rPr>
+              <a:t>  --</a:t>
+            </a:r>
+            <a:r>
+              <a:rPr lang="en-US" dirty="0" err="1">
+                <a:latin typeface="Courier New" panose="02070309020205020404" pitchFamily="49" charset="0"/>
+                <a:cs typeface="Courier New" panose="02070309020205020404" pitchFamily="49" charset="0"/>
+              </a:rPr>
+              <a:t>cov</a:t>
+            </a:r>
+            <a:r>
+              <a:rPr lang="en-US" dirty="0">
+                <a:latin typeface="Courier New" panose="02070309020205020404" pitchFamily="49" charset="0"/>
+                <a:cs typeface="Courier New" panose="02070309020205020404" pitchFamily="49" charset="0"/>
+              </a:rPr>
+              <a:t>-report=term-missing</a:t>
+            </a:r>
+            <a:br>
+              <a:rPr lang="en-US" dirty="0">
+                <a:latin typeface="Courier New" panose="02070309020205020404" pitchFamily="49" charset="0"/>
+                <a:cs typeface="Courier New" panose="02070309020205020404" pitchFamily="49" charset="0"/>
+              </a:rPr>
+            </a:br>
+            <a:r>
+              <a:rPr lang="en-US" dirty="0">
+                <a:latin typeface="Courier New" panose="02070309020205020404" pitchFamily="49" charset="0"/>
+                <a:cs typeface="Courier New" panose="02070309020205020404" pitchFamily="49" charset="0"/>
+              </a:rPr>
+              <a:t>  --</a:t>
+            </a:r>
+            <a:r>
+              <a:rPr lang="en-US" dirty="0" err="1">
+                <a:latin typeface="Courier New" panose="02070309020205020404" pitchFamily="49" charset="0"/>
+                <a:cs typeface="Courier New" panose="02070309020205020404" pitchFamily="49" charset="0"/>
+              </a:rPr>
+              <a:t>cov</a:t>
+            </a:r>
+            <a:r>
+              <a:rPr lang="en-US" dirty="0">
+                <a:latin typeface="Courier New" panose="02070309020205020404" pitchFamily="49" charset="0"/>
+                <a:cs typeface="Courier New" panose="02070309020205020404" pitchFamily="49" charset="0"/>
+              </a:rPr>
+              <a:t>-report=html</a:t>
+            </a:r>
+          </a:p>
+          <a:p>
+            <a:endParaRPr lang="en-US" dirty="0"/>
+          </a:p>
+          <a:p>
+            <a:r>
+              <a:rPr lang="en-US" dirty="0"/>
+              <a:t>What's hiding in this coverage?</a:t>
+            </a:r>
+          </a:p>
+        </p:txBody>
+      </p:sp>
+      <p:sp>
+        <p:nvSpPr>
+          <p:cNvPr id="5" name="Date Placeholder 4">
+            <a:extLst>
+              <a:ext uri="{FF2B5EF4-FFF2-40B4-BE49-F238E27FC236}">
+                <a16:creationId xmlns:a16="http://schemas.microsoft.com/office/drawing/2014/main" id="{CF2BF319-FBAB-5B5C-4508-1FF0F4B4E92A}"/>
+              </a:ext>
+            </a:extLst>
+          </p:cNvPr>
+          <p:cNvSpPr>
+            <a:spLocks noGrp="1"/>
+          </p:cNvSpPr>
+          <p:nvPr>
+            <p:ph type="dt" sz="half" idx="10"/>
           </p:nvPr>
         </p:nvSpPr>
         <p:spPr/>
@@ -26813,9 +27748,9 @@
           <a:bodyPr/>
           <a:lstStyle/>
           <a:p>
-            <a:fld id="{AD622D1A-DF83-41A8-85FF-04D90BF831D3}" type="datetime3">
+            <a:fld id="{334F72C3-CDF3-44A8-B602-1649B1728485}" type="datetime3">
               <a:rPr lang="en-US" smtClean="0"/>
-              <a:t>15 June 2026</a:t>
+              <a:t>16 June 2026</a:t>
             </a:fld>
             <a:endParaRPr lang="en-US"/>
           </a:p>
@@ -26823,18 +27758,18 @@
       </p:sp>
       <p:sp>
         <p:nvSpPr>
-          <p:cNvPr id="5" name="Slide Number Placeholder 4">
-            <a:extLst>
-              <a:ext uri="{FF2B5EF4-FFF2-40B4-BE49-F238E27FC236}">
-                <a16:creationId xmlns:a16="http://schemas.microsoft.com/office/drawing/2014/main" id="{031F3622-C14B-8E9D-151C-66C2F0F036A0}"/>
-              </a:ext>
-            </a:extLst>
-          </p:cNvPr>
-          <p:cNvSpPr>
-            <a:spLocks noGrp="1"/>
-          </p:cNvSpPr>
-          <p:nvPr>
-            <p:ph type="sldNum" idx="12"/>
+          <p:cNvPr id="6" name="Slide Number Placeholder 5">
+            <a:extLst>
+              <a:ext uri="{FF2B5EF4-FFF2-40B4-BE49-F238E27FC236}">
+                <a16:creationId xmlns:a16="http://schemas.microsoft.com/office/drawing/2014/main" id="{A21D9745-8E55-185D-FB29-9D59A6D09134}"/>
+              </a:ext>
+            </a:extLst>
+          </p:cNvPr>
+          <p:cNvSpPr>
+            <a:spLocks noGrp="1"/>
+          </p:cNvSpPr>
+          <p:nvPr>
+            <p:ph type="sldNum" sz="quarter" idx="11"/>
           </p:nvPr>
         </p:nvSpPr>
         <p:spPr/>
@@ -26851,16 +27786,240 @@
           </a:p>
         </p:txBody>
       </p:sp>
+      <p:pic>
+        <p:nvPicPr>
+          <p:cNvPr id="12" name="Content Placeholder 11">
+            <a:extLst>
+              <a:ext uri="{FF2B5EF4-FFF2-40B4-BE49-F238E27FC236}">
+                <a16:creationId xmlns:a16="http://schemas.microsoft.com/office/drawing/2014/main" id="{F3E85E4D-C78A-18C2-27EF-CA428657E9B3}"/>
+              </a:ext>
+            </a:extLst>
+          </p:cNvPr>
+          <p:cNvPicPr>
+            <a:picLocks noGrp="1" noChangeAspect="1"/>
+          </p:cNvPicPr>
+          <p:nvPr>
+            <p:ph sz="half" idx="2"/>
+          </p:nvPr>
+        </p:nvPicPr>
+        <p:blipFill>
+          <a:blip r:embed="rId3"/>
+          <a:stretch>
+            <a:fillRect/>
+          </a:stretch>
+        </p:blipFill>
+        <p:spPr>
+          <a:xfrm>
+            <a:off x="4319735" y="1151232"/>
+            <a:ext cx="4779110" cy="2996360"/>
+          </a:xfrm>
+          <a:prstGeom prst="rect">
+            <a:avLst/>
+          </a:prstGeom>
+        </p:spPr>
+      </p:pic>
     </p:spTree>
     <p:extLst>
       <p:ext uri="{BB962C8B-B14F-4D97-AF65-F5344CB8AC3E}">
-        <p14:creationId xmlns:p14="http://schemas.microsoft.com/office/powerpoint/2010/main" val="1145013977"/>
+        <p14:creationId xmlns:p14="http://schemas.microsoft.com/office/powerpoint/2010/main" val="2670643533"/>
       </p:ext>
     </p:extLst>
   </p:cSld>
   <p:clrMapOvr>
     <a:masterClrMapping/>
   </p:clrMapOvr>
+  <p:timing>
+    <p:tnLst>
+      <p:par>
+        <p:cTn id="1" dur="indefinite" restart="never" nodeType="tmRoot">
+          <p:childTnLst>
+            <p:seq concurrent="1" nextAc="seek">
+              <p:cTn id="2" dur="indefinite" nodeType="mainSeq">
+                <p:childTnLst>
+                  <p:par>
+                    <p:cTn id="3" fill="hold">
+                      <p:stCondLst>
+                        <p:cond delay="indefinite"/>
+                        <p:cond evt="onBegin" delay="0">
+                          <p:tn val="2"/>
+                        </p:cond>
+                      </p:stCondLst>
+                      <p:childTnLst>
+                        <p:par>
+                          <p:cTn id="4" fill="hold">
+                            <p:stCondLst>
+                              <p:cond delay="0"/>
+                            </p:stCondLst>
+                            <p:childTnLst>
+                              <p:par>
+                                <p:cTn id="5" presetID="1" presetClass="entr" presetSubtype="0" fill="hold" grpId="0" nodeType="withEffect">
+                                  <p:stCondLst>
+                                    <p:cond delay="0"/>
+                                  </p:stCondLst>
+                                  <p:childTnLst>
+                                    <p:set>
+                                      <p:cBhvr>
+                                        <p:cTn id="6" dur="1" fill="hold">
+                                          <p:stCondLst>
+                                            <p:cond delay="0"/>
+                                          </p:stCondLst>
+                                        </p:cTn>
+                                        <p:tgtEl>
+                                          <p:spTgt spid="3">
+                                            <p:txEl>
+                                              <p:pRg st="0" end="0"/>
+                                            </p:txEl>
+                                          </p:spTgt>
+                                        </p:tgtEl>
+                                        <p:attrNameLst>
+                                          <p:attrName>style.visibility</p:attrName>
+                                        </p:attrNameLst>
+                                      </p:cBhvr>
+                                      <p:to>
+                                        <p:strVal val="visible"/>
+                                      </p:to>
+                                    </p:set>
+                                  </p:childTnLst>
+                                </p:cTn>
+                              </p:par>
+                              <p:par>
+                                <p:cTn id="7" presetID="1" presetClass="entr" presetSubtype="0" fill="hold" grpId="0" nodeType="withEffect">
+                                  <p:stCondLst>
+                                    <p:cond delay="0"/>
+                                  </p:stCondLst>
+                                  <p:childTnLst>
+                                    <p:set>
+                                      <p:cBhvr>
+                                        <p:cTn id="8" dur="1" fill="hold">
+                                          <p:stCondLst>
+                                            <p:cond delay="0"/>
+                                          </p:stCondLst>
+                                        </p:cTn>
+                                        <p:tgtEl>
+                                          <p:spTgt spid="3">
+                                            <p:txEl>
+                                              <p:pRg st="1" end="1"/>
+                                            </p:txEl>
+                                          </p:spTgt>
+                                        </p:tgtEl>
+                                        <p:attrNameLst>
+                                          <p:attrName>style.visibility</p:attrName>
+                                        </p:attrNameLst>
+                                      </p:cBhvr>
+                                      <p:to>
+                                        <p:strVal val="visible"/>
+                                      </p:to>
+                                    </p:set>
+                                  </p:childTnLst>
+                                </p:cTn>
+                              </p:par>
+                            </p:childTnLst>
+                          </p:cTn>
+                        </p:par>
+                      </p:childTnLst>
+                    </p:cTn>
+                  </p:par>
+                  <p:par>
+                    <p:cTn id="9" fill="hold">
+                      <p:stCondLst>
+                        <p:cond delay="indefinite"/>
+                      </p:stCondLst>
+                      <p:childTnLst>
+                        <p:par>
+                          <p:cTn id="10" fill="hold">
+                            <p:stCondLst>
+                              <p:cond delay="0"/>
+                            </p:stCondLst>
+                            <p:childTnLst>
+                              <p:par>
+                                <p:cTn id="11" presetID="1" presetClass="entr" presetSubtype="0" fill="hold" grpId="0" nodeType="clickEffect">
+                                  <p:stCondLst>
+                                    <p:cond delay="0"/>
+                                  </p:stCondLst>
+                                  <p:childTnLst>
+                                    <p:set>
+                                      <p:cBhvr>
+                                        <p:cTn id="12" dur="1" fill="hold">
+                                          <p:stCondLst>
+                                            <p:cond delay="0"/>
+                                          </p:stCondLst>
+                                        </p:cTn>
+                                        <p:tgtEl>
+                                          <p:spTgt spid="3">
+                                            <p:txEl>
+                                              <p:pRg st="3" end="3"/>
+                                            </p:txEl>
+                                          </p:spTgt>
+                                        </p:tgtEl>
+                                        <p:attrNameLst>
+                                          <p:attrName>style.visibility</p:attrName>
+                                        </p:attrNameLst>
+                                      </p:cBhvr>
+                                      <p:to>
+                                        <p:strVal val="visible"/>
+                                      </p:to>
+                                    </p:set>
+                                  </p:childTnLst>
+                                </p:cTn>
+                              </p:par>
+                              <p:par>
+                                <p:cTn id="13" presetID="1" presetClass="entr" presetSubtype="0" fill="hold" nodeType="withEffect">
+                                  <p:stCondLst>
+                                    <p:cond delay="0"/>
+                                  </p:stCondLst>
+                                  <p:childTnLst>
+                                    <p:set>
+                                      <p:cBhvr>
+                                        <p:cTn id="14" dur="1" fill="hold">
+                                          <p:stCondLst>
+                                            <p:cond delay="0"/>
+                                          </p:stCondLst>
+                                        </p:cTn>
+                                        <p:tgtEl>
+                                          <p:spTgt spid="12"/>
+                                        </p:tgtEl>
+                                        <p:attrNameLst>
+                                          <p:attrName>style.visibility</p:attrName>
+                                        </p:attrNameLst>
+                                      </p:cBhvr>
+                                      <p:to>
+                                        <p:strVal val="visible"/>
+                                      </p:to>
+                                    </p:set>
+                                  </p:childTnLst>
+                                </p:cTn>
+                              </p:par>
+                            </p:childTnLst>
+                          </p:cTn>
+                        </p:par>
+                      </p:childTnLst>
+                    </p:cTn>
+                  </p:par>
+                </p:childTnLst>
+              </p:cTn>
+              <p:prevCondLst>
+                <p:cond evt="onPrev" delay="0">
+                  <p:tgtEl>
+                    <p:sldTgt/>
+                  </p:tgtEl>
+                </p:cond>
+              </p:prevCondLst>
+              <p:nextCondLst>
+                <p:cond evt="onNext" delay="0">
+                  <p:tgtEl>
+                    <p:sldTgt/>
+                  </p:tgtEl>
+                </p:cond>
+              </p:nextCondLst>
+            </p:seq>
+          </p:childTnLst>
+        </p:cTn>
+      </p:par>
+    </p:tnLst>
+    <p:bldLst>
+      <p:bldP spid="3" grpId="0" uiExpand="1" build="p"/>
+    </p:bldLst>
+  </p:timing>
 </p:sld>
 </file>
 
@@ -26883,10 +28042,10 @@
       </p:grpSpPr>
       <p:sp>
         <p:nvSpPr>
-          <p:cNvPr id="7" name="Title 6">
-            <a:extLst>
-              <a:ext uri="{FF2B5EF4-FFF2-40B4-BE49-F238E27FC236}">
-                <a16:creationId xmlns:a16="http://schemas.microsoft.com/office/drawing/2014/main" id="{D14BFEEE-7A67-A4C6-34AC-EBA551105650}"/>
+          <p:cNvPr id="2" name="Title 1">
+            <a:extLst>
+              <a:ext uri="{FF2B5EF4-FFF2-40B4-BE49-F238E27FC236}">
+                <a16:creationId xmlns:a16="http://schemas.microsoft.com/office/drawing/2014/main" id="{AFBE7449-8A14-8E4E-1773-68687CF077E7}"/>
               </a:ext>
             </a:extLst>
           </p:cNvPr>
@@ -26902,16 +28061,19 @@
           <a:bodyPr/>
           <a:lstStyle/>
           <a:p>
-            <a:endParaRPr lang="en-US"/>
-          </a:p>
-        </p:txBody>
-      </p:sp>
-      <p:sp>
-        <p:nvSpPr>
-          <p:cNvPr id="8" name="Content Placeholder 7">
-            <a:extLst>
-              <a:ext uri="{FF2B5EF4-FFF2-40B4-BE49-F238E27FC236}">
-                <a16:creationId xmlns:a16="http://schemas.microsoft.com/office/drawing/2014/main" id="{C56C219E-137A-78B0-B87B-03012C100723}"/>
+            <a:r>
+              <a:rPr lang="en-US" dirty="0"/>
+              <a:t>DRY</a:t>
+            </a:r>
+          </a:p>
+        </p:txBody>
+      </p:sp>
+      <p:sp>
+        <p:nvSpPr>
+          <p:cNvPr id="3" name="Content Placeholder 2">
+            <a:extLst>
+              <a:ext uri="{FF2B5EF4-FFF2-40B4-BE49-F238E27FC236}">
+                <a16:creationId xmlns:a16="http://schemas.microsoft.com/office/drawing/2014/main" id="{85EFD7A7-318A-9FEF-28C1-5F14AE540E72}"/>
               </a:ext>
             </a:extLst>
           </p:cNvPr>
@@ -26929,7 +28091,7 @@
           <a:p>
             <a:r>
               <a:rPr lang="en-US" dirty="0"/>
-              <a:t>Integration tests</a:t>
+              <a:t>Fixtures</a:t>
             </a:r>
           </a:p>
         </p:txBody>
@@ -26939,7 +28101,7 @@
           <p:cNvPr id="4" name="Date Placeholder 3">
             <a:extLst>
               <a:ext uri="{FF2B5EF4-FFF2-40B4-BE49-F238E27FC236}">
-                <a16:creationId xmlns:a16="http://schemas.microsoft.com/office/drawing/2014/main" id="{422F2481-E1BF-0673-AADD-550026A89217}"/>
+                <a16:creationId xmlns:a16="http://schemas.microsoft.com/office/drawing/2014/main" id="{8B55FC9A-DC16-0D9D-1583-AC865242E328}"/>
               </a:ext>
             </a:extLst>
           </p:cNvPr>
@@ -26955,16 +28117,20 @@
           <a:bodyPr/>
           <a:lstStyle/>
           <a:p>
+            <a:fld id="{AD622D1A-DF83-41A8-85FF-04D90BF831D3}" type="datetime3">
+              <a:rPr lang="en-US" smtClean="0"/>
+              <a:t>16 June 2026</a:t>
+            </a:fld>
             <a:endParaRPr lang="en-US"/>
           </a:p>
         </p:txBody>
       </p:sp>
       <p:sp>
         <p:nvSpPr>
-          <p:cNvPr id="6" name="Slide Number Placeholder 5">
-            <a:extLst>
-              <a:ext uri="{FF2B5EF4-FFF2-40B4-BE49-F238E27FC236}">
-                <a16:creationId xmlns:a16="http://schemas.microsoft.com/office/drawing/2014/main" id="{7C2A292B-1E3A-EB90-3705-C1841930EC51}"/>
+          <p:cNvPr id="5" name="Slide Number Placeholder 4">
+            <a:extLst>
+              <a:ext uri="{FF2B5EF4-FFF2-40B4-BE49-F238E27FC236}">
+                <a16:creationId xmlns:a16="http://schemas.microsoft.com/office/drawing/2014/main" id="{DB08E3C8-C147-89EA-F9F4-7977B79D869D}"/>
               </a:ext>
             </a:extLst>
           </p:cNvPr>
@@ -26980,27 +28146,19 @@
           <a:bodyPr/>
           <a:lstStyle/>
           <a:p>
-            <a:pPr marL="0" lvl="0" indent="0" algn="r" rtl="0">
-              <a:spcBef>
-                <a:spcPts val="0"/>
-              </a:spcBef>
-              <a:spcAft>
-                <a:spcPts val="0"/>
-              </a:spcAft>
-              <a:buNone/>
-            </a:pPr>
-            <a:fld id="{00000000-1234-1234-1234-123412341234}" type="slidenum">
-              <a:rPr lang="en" smtClean="0"/>
+            <a:fld id="{64E5BE4B-2FBF-4174-9E62-85FAD1CB43A6}" type="slidenum">
+              <a:rPr lang="en-US" smtClean="0"/>
+              <a:pPr/>
               <a:t>18</a:t>
             </a:fld>
-            <a:endParaRPr lang="en"/>
+            <a:endParaRPr lang="en-US"/>
           </a:p>
         </p:txBody>
       </p:sp>
     </p:spTree>
     <p:extLst>
       <p:ext uri="{BB962C8B-B14F-4D97-AF65-F5344CB8AC3E}">
-        <p14:creationId xmlns:p14="http://schemas.microsoft.com/office/powerpoint/2010/main" val="4085729229"/>
+        <p14:creationId xmlns:p14="http://schemas.microsoft.com/office/powerpoint/2010/main" val="1953408799"/>
       </p:ext>
     </p:extLst>
   </p:cSld>
@@ -27032,7 +28190,7 @@
           <p:cNvPr id="2" name="Title 1">
             <a:extLst>
               <a:ext uri="{FF2B5EF4-FFF2-40B4-BE49-F238E27FC236}">
-                <a16:creationId xmlns:a16="http://schemas.microsoft.com/office/drawing/2014/main" id="{9E04A9B4-610E-079B-1B4C-B2DA6358879D}"/>
+                <a16:creationId xmlns:a16="http://schemas.microsoft.com/office/drawing/2014/main" id="{1E90BFE8-BEA7-3940-667B-3FF6A7BCDE23}"/>
               </a:ext>
             </a:extLst>
           </p:cNvPr>
@@ -27048,7 +28206,15 @@
           <a:bodyPr/>
           <a:lstStyle/>
           <a:p>
-            <a:endParaRPr lang="en-US"/>
+            <a:r>
+              <a:rPr lang="en-US" dirty="0"/>
+              <a:t>Mocking </a:t>
+            </a:r>
+            <a:r>
+              <a:rPr lang="en-US"/>
+              <a:t>External References</a:t>
+            </a:r>
+            <a:endParaRPr lang="en-US" dirty="0"/>
           </a:p>
         </p:txBody>
       </p:sp>
@@ -27057,7 +28223,7 @@
           <p:cNvPr id="3" name="Content Placeholder 2">
             <a:extLst>
               <a:ext uri="{FF2B5EF4-FFF2-40B4-BE49-F238E27FC236}">
-                <a16:creationId xmlns:a16="http://schemas.microsoft.com/office/drawing/2014/main" id="{13371C84-11DA-CC16-E166-D409DD2E7BF8}"/>
+                <a16:creationId xmlns:a16="http://schemas.microsoft.com/office/drawing/2014/main" id="{3DFA01B0-9D70-8BBB-8D34-48A2E2EF3701}"/>
               </a:ext>
             </a:extLst>
           </p:cNvPr>
@@ -27073,7 +28239,10 @@
           <a:bodyPr/>
           <a:lstStyle/>
           <a:p>
-            <a:endParaRPr lang="en-US" dirty="0"/>
+            <a:r>
+              <a:rPr lang="en-US" dirty="0"/>
+              <a:t>Intro to mocks</a:t>
+            </a:r>
           </a:p>
         </p:txBody>
       </p:sp>
@@ -27082,7 +28251,7 @@
           <p:cNvPr id="4" name="Date Placeholder 3">
             <a:extLst>
               <a:ext uri="{FF2B5EF4-FFF2-40B4-BE49-F238E27FC236}">
-                <a16:creationId xmlns:a16="http://schemas.microsoft.com/office/drawing/2014/main" id="{F4715F3F-3A06-58A0-7854-7393E23446EF}"/>
+                <a16:creationId xmlns:a16="http://schemas.microsoft.com/office/drawing/2014/main" id="{4FFB9305-2CBA-FCFF-86FC-1A2D6F2DCA86}"/>
               </a:ext>
             </a:extLst>
           </p:cNvPr>
@@ -27100,7 +28269,7 @@
           <a:p>
             <a:fld id="{AD622D1A-DF83-41A8-85FF-04D90BF831D3}" type="datetime3">
               <a:rPr lang="en-US" smtClean="0"/>
-              <a:t>15 June 2026</a:t>
+              <a:t>16 June 2026</a:t>
             </a:fld>
             <a:endParaRPr lang="en-US"/>
           </a:p>
@@ -27111,7 +28280,7 @@
           <p:cNvPr id="5" name="Slide Number Placeholder 4">
             <a:extLst>
               <a:ext uri="{FF2B5EF4-FFF2-40B4-BE49-F238E27FC236}">
-                <a16:creationId xmlns:a16="http://schemas.microsoft.com/office/drawing/2014/main" id="{A9906345-62A7-3075-1403-F85D44D6AF85}"/>
+                <a16:creationId xmlns:a16="http://schemas.microsoft.com/office/drawing/2014/main" id="{BC24ECD0-6721-C76E-C7B4-37CC4871FADC}"/>
               </a:ext>
             </a:extLst>
           </p:cNvPr>
@@ -27139,7 +28308,7 @@
     </p:spTree>
     <p:extLst>
       <p:ext uri="{BB962C8B-B14F-4D97-AF65-F5344CB8AC3E}">
-        <p14:creationId xmlns:p14="http://schemas.microsoft.com/office/powerpoint/2010/main" val="2599536583"/>
+        <p14:creationId xmlns:p14="http://schemas.microsoft.com/office/powerpoint/2010/main" val="1276382243"/>
       </p:ext>
     </p:extLst>
   </p:cSld>
@@ -27263,7 +28432,7 @@
           <a:p>
             <a:fld id="{D41656AB-D2E1-472E-8B95-0DF5C6E1D623}" type="datetime3">
               <a:rPr lang="en-US" smtClean="0"/>
-              <a:t>15 June 2026</a:t>
+              <a:t>16 June 2026</a:t>
             </a:fld>
             <a:endParaRPr lang="en-US"/>
           </a:p>
@@ -27317,6 +28486,154 @@
   <p:cSld>
     <p:spTree>
       <p:nvGrpSpPr>
+        <p:cNvPr id="1" name="">
+          <a:extLst>
+            <a:ext uri="{FF2B5EF4-FFF2-40B4-BE49-F238E27FC236}">
+              <a16:creationId xmlns:a16="http://schemas.microsoft.com/office/drawing/2014/main" id="{324DADAD-76BA-9AB6-04D8-F96359438996}"/>
+            </a:ext>
+          </a:extLst>
+        </p:cNvPr>
+        <p:cNvGrpSpPr/>
+        <p:nvPr/>
+      </p:nvGrpSpPr>
+      <p:grpSpPr>
+        <a:xfrm>
+          <a:off x="0" y="0"/>
+          <a:ext cx="0" cy="0"/>
+          <a:chOff x="0" y="0"/>
+          <a:chExt cx="0" cy="0"/>
+        </a:xfrm>
+      </p:grpSpPr>
+      <p:sp>
+        <p:nvSpPr>
+          <p:cNvPr id="19" name="Title 18">
+            <a:extLst>
+              <a:ext uri="{FF2B5EF4-FFF2-40B4-BE49-F238E27FC236}">
+                <a16:creationId xmlns:a16="http://schemas.microsoft.com/office/drawing/2014/main" id="{36B38081-0A20-1671-69BB-F04D160E86DA}"/>
+              </a:ext>
+            </a:extLst>
+          </p:cNvPr>
+          <p:cNvSpPr>
+            <a:spLocks noGrp="1"/>
+          </p:cNvSpPr>
+          <p:nvPr>
+            <p:ph type="ctrTitle"/>
+          </p:nvPr>
+        </p:nvSpPr>
+        <p:spPr/>
+        <p:txBody>
+          <a:bodyPr/>
+          <a:lstStyle/>
+          <a:p>
+            <a:r>
+              <a:rPr lang="en-US" dirty="0"/>
+              <a:t>Integration Tests</a:t>
+            </a:r>
+          </a:p>
+        </p:txBody>
+      </p:sp>
+      <p:sp>
+        <p:nvSpPr>
+          <p:cNvPr id="20" name="Subtitle 19">
+            <a:extLst>
+              <a:ext uri="{FF2B5EF4-FFF2-40B4-BE49-F238E27FC236}">
+                <a16:creationId xmlns:a16="http://schemas.microsoft.com/office/drawing/2014/main" id="{3BA15F1A-B579-CF67-3060-C51EA22FB5C8}"/>
+              </a:ext>
+            </a:extLst>
+          </p:cNvPr>
+          <p:cNvSpPr>
+            <a:spLocks noGrp="1"/>
+          </p:cNvSpPr>
+          <p:nvPr>
+            <p:ph type="subTitle" idx="1"/>
+          </p:nvPr>
+        </p:nvSpPr>
+        <p:spPr/>
+        <p:txBody>
+          <a:bodyPr/>
+          <a:lstStyle/>
+          <a:p>
+            <a:endParaRPr lang="en-US"/>
+          </a:p>
+        </p:txBody>
+      </p:sp>
+      <p:sp>
+        <p:nvSpPr>
+          <p:cNvPr id="4" name="Date Placeholder 3">
+            <a:extLst>
+              <a:ext uri="{FF2B5EF4-FFF2-40B4-BE49-F238E27FC236}">
+                <a16:creationId xmlns:a16="http://schemas.microsoft.com/office/drawing/2014/main" id="{5EC030FD-2B80-BD4D-BA09-0A7A49C2BA76}"/>
+              </a:ext>
+            </a:extLst>
+          </p:cNvPr>
+          <p:cNvSpPr>
+            <a:spLocks noGrp="1"/>
+          </p:cNvSpPr>
+          <p:nvPr>
+            <p:ph type="dt" idx="10"/>
+          </p:nvPr>
+        </p:nvSpPr>
+        <p:spPr/>
+        <p:txBody>
+          <a:bodyPr/>
+          <a:lstStyle/>
+          <a:p>
+            <a:fld id="{AD622D1A-DF83-41A8-85FF-04D90BF831D3}" type="datetime3">
+              <a:rPr lang="en-US" smtClean="0"/>
+              <a:t>16 June 2026</a:t>
+            </a:fld>
+            <a:endParaRPr lang="en-US"/>
+          </a:p>
+        </p:txBody>
+      </p:sp>
+      <p:sp>
+        <p:nvSpPr>
+          <p:cNvPr id="5" name="Slide Number Placeholder 4">
+            <a:extLst>
+              <a:ext uri="{FF2B5EF4-FFF2-40B4-BE49-F238E27FC236}">
+                <a16:creationId xmlns:a16="http://schemas.microsoft.com/office/drawing/2014/main" id="{031F3622-C14B-8E9D-151C-66C2F0F036A0}"/>
+              </a:ext>
+            </a:extLst>
+          </p:cNvPr>
+          <p:cNvSpPr>
+            <a:spLocks noGrp="1"/>
+          </p:cNvSpPr>
+          <p:nvPr>
+            <p:ph type="sldNum" idx="12"/>
+          </p:nvPr>
+        </p:nvSpPr>
+        <p:spPr/>
+        <p:txBody>
+          <a:bodyPr/>
+          <a:lstStyle/>
+          <a:p>
+            <a:fld id="{64E5BE4B-2FBF-4174-9E62-85FAD1CB43A6}" type="slidenum">
+              <a:rPr lang="en-US" smtClean="0"/>
+              <a:pPr/>
+              <a:t>20</a:t>
+            </a:fld>
+            <a:endParaRPr lang="en-US"/>
+          </a:p>
+        </p:txBody>
+      </p:sp>
+    </p:spTree>
+    <p:extLst>
+      <p:ext uri="{BB962C8B-B14F-4D97-AF65-F5344CB8AC3E}">
+        <p14:creationId xmlns:p14="http://schemas.microsoft.com/office/powerpoint/2010/main" val="1145013977"/>
+      </p:ext>
+    </p:extLst>
+  </p:cSld>
+  <p:clrMapOvr>
+    <a:masterClrMapping/>
+  </p:clrMapOvr>
+</p:sld>
+</file>
+
+<file path=ppt/slides/slide21.xml><?xml version="1.0" encoding="utf-8"?>
+<p:sld xmlns:a="http://schemas.openxmlformats.org/drawingml/2006/main" xmlns:r="http://schemas.openxmlformats.org/officeDocument/2006/relationships" xmlns:p="http://schemas.openxmlformats.org/presentationml/2006/main">
+  <p:cSld>
+    <p:spTree>
+      <p:nvGrpSpPr>
         <p:cNvPr id="1" name=""/>
         <p:cNvGrpSpPr/>
         <p:nvPr/>
@@ -27331,6 +28648,152 @@
       </p:grpSpPr>
       <p:sp>
         <p:nvSpPr>
+          <p:cNvPr id="7" name="Title 6">
+            <a:extLst>
+              <a:ext uri="{FF2B5EF4-FFF2-40B4-BE49-F238E27FC236}">
+                <a16:creationId xmlns:a16="http://schemas.microsoft.com/office/drawing/2014/main" id="{D14BFEEE-7A67-A4C6-34AC-EBA551105650}"/>
+              </a:ext>
+            </a:extLst>
+          </p:cNvPr>
+          <p:cNvSpPr>
+            <a:spLocks noGrp="1"/>
+          </p:cNvSpPr>
+          <p:nvPr>
+            <p:ph type="title"/>
+          </p:nvPr>
+        </p:nvSpPr>
+        <p:spPr/>
+        <p:txBody>
+          <a:bodyPr/>
+          <a:lstStyle/>
+          <a:p>
+            <a:endParaRPr lang="en-US"/>
+          </a:p>
+        </p:txBody>
+      </p:sp>
+      <p:sp>
+        <p:nvSpPr>
+          <p:cNvPr id="8" name="Content Placeholder 7">
+            <a:extLst>
+              <a:ext uri="{FF2B5EF4-FFF2-40B4-BE49-F238E27FC236}">
+                <a16:creationId xmlns:a16="http://schemas.microsoft.com/office/drawing/2014/main" id="{C56C219E-137A-78B0-B87B-03012C100723}"/>
+              </a:ext>
+            </a:extLst>
+          </p:cNvPr>
+          <p:cNvSpPr>
+            <a:spLocks noGrp="1"/>
+          </p:cNvSpPr>
+          <p:nvPr>
+            <p:ph idx="1"/>
+          </p:nvPr>
+        </p:nvSpPr>
+        <p:spPr/>
+        <p:txBody>
+          <a:bodyPr/>
+          <a:lstStyle/>
+          <a:p>
+            <a:r>
+              <a:rPr lang="en-US" dirty="0"/>
+              <a:t>Integration tests</a:t>
+            </a:r>
+          </a:p>
+        </p:txBody>
+      </p:sp>
+      <p:sp>
+        <p:nvSpPr>
+          <p:cNvPr id="4" name="Date Placeholder 3">
+            <a:extLst>
+              <a:ext uri="{FF2B5EF4-FFF2-40B4-BE49-F238E27FC236}">
+                <a16:creationId xmlns:a16="http://schemas.microsoft.com/office/drawing/2014/main" id="{422F2481-E1BF-0673-AADD-550026A89217}"/>
+              </a:ext>
+            </a:extLst>
+          </p:cNvPr>
+          <p:cNvSpPr>
+            <a:spLocks noGrp="1"/>
+          </p:cNvSpPr>
+          <p:nvPr>
+            <p:ph type="dt" sz="half" idx="10"/>
+          </p:nvPr>
+        </p:nvSpPr>
+        <p:spPr/>
+        <p:txBody>
+          <a:bodyPr/>
+          <a:lstStyle/>
+          <a:p>
+            <a:endParaRPr lang="en-US"/>
+          </a:p>
+        </p:txBody>
+      </p:sp>
+      <p:sp>
+        <p:nvSpPr>
+          <p:cNvPr id="6" name="Slide Number Placeholder 5">
+            <a:extLst>
+              <a:ext uri="{FF2B5EF4-FFF2-40B4-BE49-F238E27FC236}">
+                <a16:creationId xmlns:a16="http://schemas.microsoft.com/office/drawing/2014/main" id="{7C2A292B-1E3A-EB90-3705-C1841930EC51}"/>
+              </a:ext>
+            </a:extLst>
+          </p:cNvPr>
+          <p:cNvSpPr>
+            <a:spLocks noGrp="1"/>
+          </p:cNvSpPr>
+          <p:nvPr>
+            <p:ph type="sldNum" sz="quarter" idx="11"/>
+          </p:nvPr>
+        </p:nvSpPr>
+        <p:spPr/>
+        <p:txBody>
+          <a:bodyPr/>
+          <a:lstStyle/>
+          <a:p>
+            <a:pPr marL="0" lvl="0" indent="0" algn="r" rtl="0">
+              <a:spcBef>
+                <a:spcPts val="0"/>
+              </a:spcBef>
+              <a:spcAft>
+                <a:spcPts val="0"/>
+              </a:spcAft>
+              <a:buNone/>
+            </a:pPr>
+            <a:fld id="{00000000-1234-1234-1234-123412341234}" type="slidenum">
+              <a:rPr lang="en" smtClean="0"/>
+              <a:t>21</a:t>
+            </a:fld>
+            <a:endParaRPr lang="en"/>
+          </a:p>
+        </p:txBody>
+      </p:sp>
+    </p:spTree>
+    <p:extLst>
+      <p:ext uri="{BB962C8B-B14F-4D97-AF65-F5344CB8AC3E}">
+        <p14:creationId xmlns:p14="http://schemas.microsoft.com/office/powerpoint/2010/main" val="4085729229"/>
+      </p:ext>
+    </p:extLst>
+  </p:cSld>
+  <p:clrMapOvr>
+    <a:masterClrMapping/>
+  </p:clrMapOvr>
+</p:sld>
+</file>
+
+<file path=ppt/slides/slide22.xml><?xml version="1.0" encoding="utf-8"?>
+<p:sld xmlns:a="http://schemas.openxmlformats.org/drawingml/2006/main" xmlns:r="http://schemas.openxmlformats.org/officeDocument/2006/relationships" xmlns:p="http://schemas.openxmlformats.org/presentationml/2006/main">
+  <p:cSld>
+    <p:spTree>
+      <p:nvGrpSpPr>
+        <p:cNvPr id="1" name=""/>
+        <p:cNvGrpSpPr/>
+        <p:nvPr/>
+      </p:nvGrpSpPr>
+      <p:grpSpPr>
+        <a:xfrm>
+          <a:off x="0" y="0"/>
+          <a:ext cx="0" cy="0"/>
+          <a:chOff x="0" y="0"/>
+          <a:chExt cx="0" cy="0"/>
+        </a:xfrm>
+      </p:grpSpPr>
+      <p:sp>
+        <p:nvSpPr>
           <p:cNvPr id="7" name="Subtitle 6">
             <a:extLst>
               <a:ext uri="{FF2B5EF4-FFF2-40B4-BE49-F238E27FC236}">
@@ -27387,7 +28850,7 @@
           <a:p>
             <a:fld id="{AD622D1A-DF83-41A8-85FF-04D90BF831D3}" type="datetime3">
               <a:rPr lang="en-US" smtClean="0"/>
-              <a:t>15 June 2026</a:t>
+              <a:t>16 June 2026</a:t>
             </a:fld>
             <a:endParaRPr lang="en-US"/>
           </a:p>
@@ -27417,7 +28880,7 @@
             <a:fld id="{64E5BE4B-2FBF-4174-9E62-85FAD1CB43A6}" type="slidenum">
               <a:rPr lang="en-US" smtClean="0"/>
               <a:pPr/>
-              <a:t>20</a:t>
+              <a:t>22</a:t>
             </a:fld>
             <a:endParaRPr lang="en-US"/>
           </a:p>
@@ -27532,7 +28995,7 @@
           <a:p>
             <a:fld id="{AD622D1A-DF83-41A8-85FF-04D90BF831D3}" type="datetime3">
               <a:rPr lang="en-US" smtClean="0"/>
-              <a:t>15 June 2026</a:t>
+              <a:t>16 June 2026</a:t>
             </a:fld>
             <a:endParaRPr lang="en-US"/>
           </a:p>
@@ -27719,7 +29182,7 @@
           <a:p>
             <a:fld id="{AD622D1A-DF83-41A8-85FF-04D90BF831D3}" type="datetime3">
               <a:rPr lang="en-US" smtClean="0"/>
-              <a:t>15 June 2026</a:t>
+              <a:t>16 June 2026</a:t>
             </a:fld>
             <a:endParaRPr lang="en-US"/>
           </a:p>
@@ -28014,7 +29477,7 @@
             <a:fld id="{AD622D1A-DF83-41A8-85FF-04D90BF831D3}" type="datetime3">
               <a:rPr lang="en-US" smtClean="0"/>
               <a:pPr/>
-              <a:t>15 June 2026</a:t>
+              <a:t>16 June 2026</a:t>
             </a:fld>
             <a:endParaRPr lang="en-US"/>
           </a:p>
@@ -28294,7 +29757,7 @@
           <a:p>
             <a:fld id="{AD622D1A-DF83-41A8-85FF-04D90BF831D3}" type="datetime3">
               <a:rPr lang="en-US" smtClean="0"/>
-              <a:t>15 June 2026</a:t>
+              <a:t>16 June 2026</a:t>
             </a:fld>
             <a:endParaRPr lang="en-US"/>
           </a:p>
@@ -28478,7 +29941,7 @@
           <a:p>
             <a:fld id="{AD622D1A-DF83-41A8-85FF-04D90BF831D3}" type="datetime3">
               <a:rPr lang="en-US" smtClean="0"/>
-              <a:t>15 June 2026</a:t>
+              <a:t>16 June 2026</a:t>
             </a:fld>
             <a:endParaRPr lang="en-US"/>
           </a:p>
@@ -28724,7 +30187,7 @@
           <a:p>
             <a:fld id="{AD622D1A-DF83-41A8-85FF-04D90BF831D3}" type="datetime3">
               <a:rPr lang="en-US" smtClean="0"/>
-              <a:t>15 June 2026</a:t>
+              <a:t>16 June 2026</a:t>
             </a:fld>
             <a:endParaRPr lang="en-US"/>
           </a:p>
@@ -28838,7 +30301,7 @@
           <a:p>
             <a:fld id="{AD622D1A-DF83-41A8-85FF-04D90BF831D3}" type="datetime3">
               <a:rPr lang="en-US" smtClean="0"/>
-              <a:t>15 June 2026</a:t>
+              <a:t>16 June 2026</a:t>
             </a:fld>
             <a:endParaRPr lang="en-US"/>
           </a:p>

</xml_diff>